<commit_message>
PPT v5: layout corregido slides 7-8, sin solapamientos
- Todo el contenido empieza en y=2.22 (después que el título termina en y=2.20)
- Sin placeholders <p:ph> conflictivos — solo auto_shapes y text_boxes
- Header negro/dorado con sp_header_dark (solidFill tx1 + texto FFC000)
- Bloques: título accent1 (h=0.32) + descripción tint claro (h=0.52) × 5
- Panel derecho con degradado dk1, dos secciones con texto blanco
- normAutofit en todos los cuadros para evitar overflow de texto

https://claude.ai/code/session_01Wu4J5kMW3gnyas1BwZ5v9s
</commit_message>
<xml_diff>
--- a/Caso86_Presentacion.pptx
+++ b/Caso86_Presentacion.pptx
@@ -12317,78 +12317,34 @@
       </p:sp>
       <p:sp>
         <p:nvSpPr>
-          <p:cNvPr id="100" name="Header7"/>
-          <p:cNvSpPr>
-            <a:spLocks noGrp="1"/>
-          </p:cNvSpPr>
-          <p:nvPr>
-            <p:ph type="body" idx="1"/>
-          </p:nvPr>
-        </p:nvSpPr>
-        <p:spPr>
-          <a:xfrm>
-            <a:off x="594360" y="1362456"/>
-            <a:ext cx="6428232" cy="502920"/>
-          </a:xfrm>
-          <a:solidFill>
-            <a:schemeClr val="tx1">
-              <a:alpha val="74000"/>
-            </a:schemeClr>
-          </a:solidFill>
-        </p:spPr>
-        <p:txBody>
-          <a:bodyPr/>
-          <a:lstStyle/>
-          <a:p>
-            <a:r>
-              <a:rPr lang="es-CL" dirty="0">
-                <a:solidFill>
-                  <a:srgbClr val="FFC000"/>
-                </a:solidFill>
-              </a:rPr>
-              <a:t>Alternativas de solución</a:t>
-            </a:r>
-          </a:p>
-        </p:txBody>
-      </p:sp>
-      <p:sp>
-        <p:nvSpPr>
-          <p:cNvPr id="101" name="PanelOscuro 101"/>
+          <p:cNvPr id="100" name="Panel100"/>
           <p:cNvSpPr/>
           <p:nvPr/>
         </p:nvSpPr>
         <p:spPr>
           <a:xfrm>
-            <a:off x="7132320" y="1362456"/>
-            <a:ext cx="4462272" cy="5047488"/>
+            <a:off x="6858000" y="2029968"/>
+            <a:ext cx="5120640" cy="4626864"/>
           </a:xfrm>
           <a:prstGeom prst="rect">
             <a:avLst/>
           </a:prstGeom>
           <a:gradFill>
             <a:gsLst>
-              <a:gs pos="73000">
+              <a:gs pos="0">
                 <a:schemeClr val="dk1">
-                  <a:tint val="60000"/>
+                  <a:tint val="55000"/>
                   <a:satMod val="105000"/>
-                  <a:lumMod val="105000"/>
-                </a:schemeClr>
-              </a:gs>
-              <a:gs pos="100000">
-                <a:schemeClr val="dk1">
-                  <a:tint val="65000"/>
-                  <a:satMod val="100000"/>
-                  <a:lumMod val="100000"/>
                 </a:schemeClr>
               </a:gs>
               <a:gs pos="100000">
                 <a:schemeClr val="dk1">
                   <a:tint val="70000"/>
                   <a:satMod val="100000"/>
-                  <a:lumMod val="100000"/>
                 </a:schemeClr>
               </a:gs>
             </a:gsLst>
+            <a:lin ang="5400000" scaled="0"/>
           </a:gradFill>
         </p:spPr>
         <p:style>
@@ -12406,7 +12362,7 @@
           </a:fontRef>
         </p:style>
         <p:txBody>
-          <a:bodyPr rtlCol="0" anchor="ctr"/>
+          <a:bodyPr/>
           <a:lstStyle/>
           <a:p>
             <a:endParaRPr lang="es-CL" dirty="0"/>
@@ -12415,14 +12371,14 @@
       </p:sp>
       <p:sp>
         <p:nvSpPr>
-          <p:cNvPr id="102" name="TB 102"/>
+          <p:cNvPr id="101" name="TB101"/>
           <p:cNvSpPr txBox="1"/>
           <p:nvPr/>
         </p:nvSpPr>
         <p:spPr>
           <a:xfrm>
-            <a:off x="7242048" y="1453896"/>
-            <a:ext cx="4242816" cy="411480"/>
+            <a:off x="6986016" y="2139696"/>
+            <a:ext cx="4864607" cy="2148840"/>
           </a:xfrm>
           <a:prstGeom prst="rect">
             <a:avLst/>
@@ -12430,45 +12386,26 @@
           <a:noFill/>
         </p:spPr>
         <p:txBody>
-          <a:bodyPr wrap="square" rtlCol="0"/>
+          <a:bodyPr wrap="square" rtlCol="0">
+            <a:normAutofit/>
+          </a:bodyPr>
           <a:lstStyle/>
           <a:p>
-            <a:pPr algn="ctr"/>
-            <a:r>
-              <a:rPr lang="es-CL" sz="1300" dirty="0">
+            <a:r>
+              <a:rPr lang="es-CL" sz="1200" b="1" dirty="0">
                 <a:solidFill>
                   <a:srgbClr val="FFC000"/>
                 </a:solidFill>
-                <a:b>1</a:b>
               </a:rPr>
-              <a:t>Consideraciones importantes</a:t>
-            </a:r>
-          </a:p>
-        </p:txBody>
-      </p:sp>
-      <p:sp>
-        <p:nvSpPr>
-          <p:cNvPr id="103" name="TB 103"/>
-          <p:cNvSpPr txBox="1"/>
-          <p:nvPr/>
-        </p:nvSpPr>
-        <p:spPr>
-          <a:xfrm>
-            <a:off x="7242048" y="1911095"/>
-            <a:ext cx="4242816" cy="2103120"/>
-          </a:xfrm>
-          <a:prstGeom prst="rect">
-            <a:avLst/>
-          </a:prstGeom>
-          <a:noFill/>
-        </p:spPr>
-        <p:txBody>
-          <a:bodyPr wrap="square" rtlCol="0"/>
-          <a:lstStyle/>
-          <a:p>
-            <a:pPr algn="l"/>
-            <a:r>
-              <a:rPr lang="es-CL" sz="1000" dirty="0">
+              <a:t>Consideraciones</a:t>
+            </a:r>
+          </a:p>
+          <a:p>
+            <a:endParaRPr lang="es-CL" sz="600" dirty="0"/>
+          </a:p>
+          <a:p>
+            <a:r>
+              <a:rPr lang="es-CL" sz="980" dirty="0">
                 <a:solidFill>
                   <a:srgbClr val="FFFFFF"/>
                 </a:solidFill>
@@ -12477,31 +12414,38 @@
             </a:r>
           </a:p>
           <a:p>
-            <a:pPr algn="l"/>
-            <a:r>
-              <a:rPr lang="es-CL" sz="1000" dirty="0">
+            <a:r>
+              <a:rPr lang="es-CL" sz="980" dirty="0">
                 <a:solidFill>
                   <a:srgbClr val="FFFFFF"/>
                 </a:solidFill>
               </a:rPr>
-              <a:t>válida frente a las NGA, debe poder</a:t>
-            </a:r>
-          </a:p>
-          <a:p>
-            <a:pPr algn="l"/>
-            <a:r>
-              <a:rPr lang="es-CL" sz="1000" dirty="0">
+              <a:t>válida frente a las NGA, el socio</a:t>
+            </a:r>
+          </a:p>
+          <a:p>
+            <a:r>
+              <a:rPr lang="es-CL" sz="980" dirty="0">
                 <a:solidFill>
                   <a:srgbClr val="FFFFFF"/>
                 </a:solidFill>
               </a:rPr>
-              <a:t>acreditar SUSTANCIA ECONÓMICA REAL:</a:t>
-            </a:r>
-          </a:p>
-          <a:p>
-            <a:pPr algn="l"/>
-            <a:r>
-              <a:rPr lang="es-CL" sz="1000" dirty="0">
+              <a:t>debe poder acreditar SUSTANCIA</a:t>
+            </a:r>
+          </a:p>
+          <a:p>
+            <a:r>
+              <a:rPr lang="es-CL" sz="980" dirty="0">
+                <a:solidFill>
+                  <a:srgbClr val="FFFFFF"/>
+                </a:solidFill>
+              </a:rPr>
+              <a:t>ECONÓMICA REAL:</a:t>
+            </a:r>
+          </a:p>
+          <a:p>
+            <a:r>
+              <a:rPr lang="es-CL" sz="980" dirty="0">
                 <a:solidFill>
                   <a:srgbClr val="FFFFFF"/>
                 </a:solidFill>
@@ -12510,214 +12454,228 @@
             </a:r>
           </a:p>
           <a:p>
-            <a:pPr algn="l"/>
-            <a:r>
-              <a:rPr lang="es-CL" sz="1000" dirty="0">
+            <a:r>
+              <a:rPr lang="es-CL" sz="980" dirty="0">
                 <a:solidFill>
                   <a:srgbClr val="FFFFFF"/>
                 </a:solidFill>
               </a:rPr>
-              <a:t>▪  Todos los socios deben ejercer</a:t>
-            </a:r>
-          </a:p>
-          <a:p>
-            <a:pPr algn="l"/>
-            <a:r>
-              <a:rPr lang="es-CL" sz="1000" dirty="0">
+              <a:t>• Todos los socios deben ejercer su</a:t>
+            </a:r>
+          </a:p>
+          <a:p>
+            <a:r>
+              <a:rPr lang="es-CL" sz="980" dirty="0">
                 <a:solidFill>
                   <a:srgbClr val="FFFFFF"/>
                 </a:solidFill>
               </a:rPr>
-              <a:t>    su profesión para la sociedad.</a:t>
-            </a:r>
-          </a:p>
-          <a:p>
-            <a:pPr algn="l"/>
-            <a:r>
-              <a:rPr lang="es-CL" sz="1000" dirty="0">
+              <a:t>  profesión para la sociedad.</a:t>
+            </a:r>
+          </a:p>
+          <a:p>
+            <a:r>
+              <a:rPr lang="es-CL" sz="980" dirty="0">
                 <a:solidFill>
                   <a:srgbClr val="FFFFFF"/>
                 </a:solidFill>
               </a:rPr>
-              <a:t/>
-            </a:r>
-          </a:p>
-          <a:p>
-            <a:pPr algn="l"/>
-            <a:r>
-              <a:rPr lang="es-CL" sz="1000" dirty="0">
+              <a:t>• La distribución de utilidades debe</a:t>
+            </a:r>
+          </a:p>
+          <a:p>
+            <a:r>
+              <a:rPr lang="es-CL" sz="980" dirty="0">
                 <a:solidFill>
                   <a:srgbClr val="FFFFFF"/>
                 </a:solidFill>
               </a:rPr>
-              <a:t>▪  La distribución de utilidades debe</a:t>
-            </a:r>
-          </a:p>
-          <a:p>
-            <a:pPr algn="l"/>
-            <a:r>
-              <a:rPr lang="es-CL" sz="1000" dirty="0">
+              <a:t>  reflejar el aporte efectivo.</a:t>
+            </a:r>
+          </a:p>
+          <a:p>
+            <a:r>
+              <a:rPr lang="es-CL" sz="980" dirty="0">
                 <a:solidFill>
                   <a:srgbClr val="FFFFFF"/>
                 </a:solidFill>
               </a:rPr>
-              <a:t>    reflejar el aporte efectivo.</a:t>
-            </a:r>
-          </a:p>
-          <a:p>
-            <a:pPr algn="l"/>
-            <a:r>
-              <a:rPr lang="es-CL" sz="1000" dirty="0">
+              <a:t>• El capital debe ser significativo</a:t>
+            </a:r>
+          </a:p>
+          <a:p>
+            <a:r>
+              <a:rPr lang="es-CL" sz="980" dirty="0">
                 <a:solidFill>
                   <a:srgbClr val="FFFFFF"/>
                 </a:solidFill>
               </a:rPr>
-              <a:t/>
-            </a:r>
-          </a:p>
-          <a:p>
-            <a:pPr algn="l"/>
-            <a:r>
-              <a:rPr lang="es-CL" sz="1000" dirty="0">
+              <a:t>  respecto a los ingresos.</a:t>
+            </a:r>
+          </a:p>
+        </p:txBody>
+      </p:sp>
+      <p:sp>
+        <p:nvSpPr>
+          <p:cNvPr id="102" name="TB102"/>
+          <p:cNvSpPr txBox="1"/>
+          <p:nvPr/>
+        </p:nvSpPr>
+        <p:spPr>
+          <a:xfrm>
+            <a:off x="6986016" y="4407408"/>
+            <a:ext cx="4864607" cy="2148840"/>
+          </a:xfrm>
+          <a:prstGeom prst="rect">
+            <a:avLst/>
+          </a:prstGeom>
+          <a:noFill/>
+        </p:spPr>
+        <p:txBody>
+          <a:bodyPr wrap="square" rtlCol="0">
+            <a:normAutofit/>
+          </a:bodyPr>
+          <a:lstStyle/>
+          <a:p>
+            <a:r>
+              <a:rPr lang="es-CL" sz="1200" b="1" dirty="0">
+                <a:solidFill>
+                  <a:srgbClr val="FFC000"/>
+                </a:solidFill>
+              </a:rPr>
+              <a:t>Normativa de referencia</a:t>
+            </a:r>
+          </a:p>
+          <a:p>
+            <a:endParaRPr lang="es-CL" sz="600" dirty="0"/>
+          </a:p>
+          <a:p>
+            <a:r>
+              <a:rPr lang="es-CL" sz="980" dirty="0">
                 <a:solidFill>
                   <a:srgbClr val="FFFFFF"/>
                 </a:solidFill>
               </a:rPr>
-              <a:t>▪  El capital debe ser relevante en</a:t>
-            </a:r>
-          </a:p>
-          <a:p>
-            <a:pPr algn="l"/>
-            <a:r>
-              <a:rPr lang="es-CL" sz="1000" dirty="0">
+              <a:t>• Art. 42 N°2 LIR</a:t>
+            </a:r>
+          </a:p>
+          <a:p>
+            <a:r>
+              <a:rPr lang="es-CL" sz="980" dirty="0">
                 <a:solidFill>
                   <a:srgbClr val="FFFFFF"/>
                 </a:solidFill>
               </a:rPr>
-              <a:t>    relación a los ingresos.</a:t>
-            </a:r>
-          </a:p>
-        </p:txBody>
-      </p:sp>
-      <p:sp>
-        <p:nvSpPr>
-          <p:cNvPr id="104" name="TB 104"/>
-          <p:cNvSpPr txBox="1"/>
-          <p:nvPr/>
-        </p:nvSpPr>
-        <p:spPr>
-          <a:xfrm>
-            <a:off x="7242048" y="4151376"/>
-            <a:ext cx="4242816" cy="411480"/>
-          </a:xfrm>
-          <a:prstGeom prst="rect">
-            <a:avLst/>
-          </a:prstGeom>
-          <a:noFill/>
-        </p:spPr>
-        <p:txBody>
-          <a:bodyPr wrap="square" rtlCol="0"/>
-          <a:lstStyle/>
-          <a:p>
-            <a:pPr algn="ctr"/>
-            <a:r>
-              <a:rPr lang="es-CL" sz="1200" dirty="0">
-                <a:solidFill>
-                  <a:srgbClr val="FFC000"/>
-                </a:solidFill>
-                <a:b>1</a:b>
-              </a:rPr>
-              <a:t>Normativa de referencia</a:t>
-            </a:r>
-          </a:p>
-        </p:txBody>
-      </p:sp>
-      <p:sp>
-        <p:nvSpPr>
-          <p:cNvPr id="105" name="TB 105"/>
-          <p:cNvSpPr txBox="1"/>
-          <p:nvPr/>
-        </p:nvSpPr>
-        <p:spPr>
-          <a:xfrm>
-            <a:off x="7242048" y="4608576"/>
-            <a:ext cx="4242816" cy="1691640"/>
-          </a:xfrm>
-          <a:prstGeom prst="rect">
-            <a:avLst/>
-          </a:prstGeom>
-          <a:noFill/>
-        </p:spPr>
-        <p:txBody>
-          <a:bodyPr wrap="square" rtlCol="0"/>
-          <a:lstStyle/>
-          <a:p>
-            <a:pPr algn="l"/>
-            <a:r>
-              <a:rPr lang="es-CL" sz="1000" dirty="0">
+              <a:t>  Rentas 2ª categoría</a:t>
+            </a:r>
+          </a:p>
+          <a:p>
+            <a:r>
+              <a:rPr lang="es-CL" sz="980" dirty="0">
                 <a:solidFill>
                   <a:srgbClr val="FFFFFF"/>
                 </a:solidFill>
               </a:rPr>
-              <a:t>▪  Art. 42 N°2 LIR — rentas 2ª cat.</a:t>
-            </a:r>
-          </a:p>
-          <a:p>
-            <a:pPr algn="l"/>
-            <a:r>
-              <a:rPr lang="es-CL" sz="1000" dirty="0">
+              <a:t>• Art. 14 D N°3 y N°8 LIR</a:t>
+            </a:r>
+          </a:p>
+          <a:p>
+            <a:r>
+              <a:rPr lang="es-CL" sz="980" dirty="0">
                 <a:solidFill>
                   <a:srgbClr val="FFFFFF"/>
                 </a:solidFill>
               </a:rPr>
-              <a:t>▪  Art. 14 D N°3 y N°8 LIR — regímenes</a:t>
-            </a:r>
-          </a:p>
-          <a:p>
-            <a:pPr algn="l"/>
-            <a:r>
-              <a:rPr lang="es-CL" sz="1000" dirty="0">
+              <a:t>  Regímenes Pro Pyme</a:t>
+            </a:r>
+          </a:p>
+          <a:p>
+            <a:r>
+              <a:rPr lang="es-CL" sz="980" dirty="0">
                 <a:solidFill>
                   <a:srgbClr val="FFFFFF"/>
                 </a:solidFill>
               </a:rPr>
-              <a:t>▪  Arts. 4 bis y 4 ter CT — NGA</a:t>
-            </a:r>
-          </a:p>
-          <a:p>
-            <a:pPr algn="l"/>
-            <a:r>
-              <a:rPr lang="es-CL" sz="1000" dirty="0">
+              <a:t>• Arts. 4 bis y 4 ter CT</a:t>
+            </a:r>
+          </a:p>
+          <a:p>
+            <a:r>
+              <a:rPr lang="es-CL" sz="980" dirty="0">
                 <a:solidFill>
                   <a:srgbClr val="FFFFFF"/>
                 </a:solidFill>
               </a:rPr>
-              <a:t>▪  Circ. N°21/1991 y N°50/2020 SII</a:t>
-            </a:r>
-          </a:p>
-          <a:p>
-            <a:pPr algn="l"/>
-            <a:r>
-              <a:rPr lang="es-CL" sz="1000" dirty="0">
+              <a:t>  Normas generales antielusivas</a:t>
+            </a:r>
+          </a:p>
+          <a:p>
+            <a:r>
+              <a:rPr lang="es-CL" sz="980" dirty="0">
                 <a:solidFill>
                   <a:srgbClr val="FFFFFF"/>
                 </a:solidFill>
               </a:rPr>
-              <a:t>▪  Circ. N°65/2015 SII</a:t>
-            </a:r>
-          </a:p>
-        </p:txBody>
-      </p:sp>
-      <p:sp>
-        <p:nvSpPr>
-          <p:cNvPr id="110" name="Rect 110"/>
+              <a:t>• Circ. N°21/1991 y N°50/2020 SII</a:t>
+            </a:r>
+          </a:p>
+          <a:p>
+            <a:r>
+              <a:rPr lang="es-CL" sz="980" dirty="0">
+                <a:solidFill>
+                  <a:srgbClr val="FFFFFF"/>
+                </a:solidFill>
+              </a:rPr>
+              <a:t>• Circ. N°65/2015 SII</a:t>
+            </a:r>
+          </a:p>
+        </p:txBody>
+      </p:sp>
+      <p:sp>
+        <p:nvSpPr>
+          <p:cNvPr id="103" name="Hdr103"/>
           <p:cNvSpPr/>
           <p:nvPr/>
         </p:nvSpPr>
         <p:spPr>
           <a:xfrm>
-            <a:off x="594360" y="1920240"/>
-            <a:ext cx="6428232" cy="320040"/>
+            <a:off x="457200" y="2029968"/>
+            <a:ext cx="6309360" cy="420624"/>
+          </a:xfrm>
+          <a:prstGeom prst="rect">
+            <a:avLst/>
+          </a:prstGeom>
+          <a:solidFill>
+            <a:schemeClr val="tx1">
+              <a:alpha val="82000"/>
+            </a:schemeClr>
+          </a:solidFill>
+        </p:spPr>
+        <p:txBody>
+          <a:bodyPr rtlCol="0" anchor="ctr"/>
+          <a:lstStyle/>
+          <a:p>
+            <a:r>
+              <a:rPr lang="es-CL" sz="1600" b="1" dirty="0">
+                <a:solidFill>
+                  <a:srgbClr val="FFC000"/>
+                </a:solidFill>
+              </a:rPr>
+              <a:t>Alternativas de solución</a:t>
+            </a:r>
+          </a:p>
+        </p:txBody>
+      </p:sp>
+      <p:sp>
+        <p:nvSpPr>
+          <p:cNvPr id="110" name="Rect110"/>
+          <p:cNvSpPr/>
+          <p:nvPr/>
+        </p:nvSpPr>
+        <p:spPr>
+          <a:xfrm>
+            <a:off x="457200" y="2487168"/>
+            <a:ext cx="6309360" cy="292608"/>
           </a:xfrm>
           <a:prstGeom prst="rect">
             <a:avLst/>
@@ -12740,7 +12698,9 @@
           </a:fontRef>
         </p:style>
         <p:txBody>
-          <a:bodyPr rtlCol="0" anchor="ctr"/>
+          <a:bodyPr rtlCol="0" anchor="ctr">
+            <a:normAutofit/>
+          </a:bodyPr>
           <a:lstStyle/>
           <a:p>
             <a:r>
@@ -12754,64 +12714,48 @@
       </p:sp>
       <p:sp>
         <p:nvSpPr>
-          <p:cNvPr id="111" name="AltDesc0"/>
+          <p:cNvPr id="111" name="Desc111"/>
           <p:cNvSpPr/>
           <p:nvPr/>
         </p:nvSpPr>
         <p:spPr>
           <a:xfrm>
-            <a:off x="594360" y="2240280"/>
-            <a:ext cx="6428232" cy="429768"/>
+            <a:off x="457200" y="2779776"/>
+            <a:ext cx="6309360" cy="475488"/>
           </a:xfrm>
           <a:prstGeom prst="rect">
             <a:avLst/>
           </a:prstGeom>
-        </p:spPr>
-        <p:style>
-          <a:lnRef idx="2">
-            <a:schemeClr val="accent1">
-              <a:shade val="50000"/>
-            </a:schemeClr>
-          </a:lnRef>
-          <a:fillRef idx="2">
+          <a:solidFill>
             <a:schemeClr val="accent1">
               <a:tint val="20000"/>
             </a:schemeClr>
-          </a:fillRef>
-          <a:effectRef idx="0">
-            <a:schemeClr val="accent1"/>
-          </a:effectRef>
-          <a:fontRef idx="minor">
-            <a:schemeClr val="dk1"/>
-          </a:fontRef>
-        </p:style>
-        <p:txBody>
-          <a:bodyPr rtlCol="0" anchor="ctr"/>
+          </a:solidFill>
+        </p:spPr>
+        <p:txBody>
+          <a:bodyPr rtlCol="0" anchor="ctr">
+            <a:normAutofit/>
+          </a:bodyPr>
           <a:lstStyle/>
           <a:p>
-            <a:r>
-              <a:rPr lang="es-CL" sz="950" dirty="0"/>
-              <a:t>A ejerce como persona natural. Emite boletas de honorarios. Gastos efectivos</a:t>
-            </a:r>
-          </a:p>
-          <a:p>
-            <a:r>
-              <a:rPr lang="es-CL" sz="950" dirty="0"/>
-              <a:t>o presuntos (30%, tope 15 UTA). Paga IGC sobre el total. Sin riesgo NGA.</a:t>
-            </a:r>
-          </a:p>
-        </p:txBody>
-      </p:sp>
-      <p:sp>
-        <p:nvSpPr>
-          <p:cNvPr id="112" name="Rect 112"/>
+            <a:pPr marL="114300" indent="-114300"/>
+            <a:r>
+              <a:rPr lang="es-CL" sz="1000" dirty="0"/>
+              <a:t>A ejerce como persona natural, emite boletas de honorarios. Puede deducir gastos efectivos o presuntos (30%, tope 15 UTA). Paga IGC sobre el total. Sin riesgo NGA.</a:t>
+            </a:r>
+          </a:p>
+        </p:txBody>
+      </p:sp>
+      <p:sp>
+        <p:nvSpPr>
+          <p:cNvPr id="112" name="Rect112"/>
           <p:cNvSpPr/>
           <p:nvPr/>
         </p:nvSpPr>
         <p:spPr>
           <a:xfrm>
-            <a:off x="594360" y="2724912"/>
-            <a:ext cx="6428232" cy="320040"/>
+            <a:off x="457200" y="3310128"/>
+            <a:ext cx="6309360" cy="292608"/>
           </a:xfrm>
           <a:prstGeom prst="rect">
             <a:avLst/>
@@ -12834,7 +12778,9 @@
           </a:fontRef>
         </p:style>
         <p:txBody>
-          <a:bodyPr rtlCol="0" anchor="ctr"/>
+          <a:bodyPr rtlCol="0" anchor="ctr">
+            <a:normAutofit/>
+          </a:bodyPr>
           <a:lstStyle/>
           <a:p>
             <a:r>
@@ -12848,64 +12794,48 @@
       </p:sp>
       <p:sp>
         <p:nvSpPr>
-          <p:cNvPr id="113" name="AltDesc1"/>
+          <p:cNvPr id="113" name="Desc113"/>
           <p:cNvSpPr/>
           <p:nvPr/>
         </p:nvSpPr>
         <p:spPr>
           <a:xfrm>
-            <a:off x="594360" y="3044952"/>
-            <a:ext cx="6428232" cy="429768"/>
+            <a:off x="457200" y="3602736"/>
+            <a:ext cx="6309360" cy="475488"/>
           </a:xfrm>
           <a:prstGeom prst="rect">
             <a:avLst/>
           </a:prstGeom>
-        </p:spPr>
-        <p:style>
-          <a:lnRef idx="2">
-            <a:schemeClr val="accent1">
-              <a:shade val="50000"/>
-            </a:schemeClr>
-          </a:lnRef>
-          <a:fillRef idx="2">
+          <a:solidFill>
             <a:schemeClr val="accent1">
               <a:tint val="20000"/>
             </a:schemeClr>
-          </a:fillRef>
-          <a:effectRef idx="0">
-            <a:schemeClr val="accent1"/>
-          </a:effectRef>
-          <a:fontRef idx="minor">
-            <a:schemeClr val="dk1"/>
-          </a:fontRef>
-        </p:style>
-        <p:txBody>
-          <a:bodyPr rtlCol="0" anchor="ctr"/>
+          </a:solidFill>
+        </p:spPr>
+        <p:txBody>
+          <a:bodyPr rtlCol="0" anchor="ctr">
+            <a:normAutofit/>
+          </a:bodyPr>
           <a:lstStyle/>
           <a:p>
-            <a:r>
-              <a:rPr lang="es-CL" sz="950" dirty="0"/>
-              <a:t>A se asocia con profesionales que efectivamente presten servicios</a:t>
-            </a:r>
-          </a:p>
-          <a:p>
-            <a:r>
-              <a:rPr lang="es-CL" sz="950" dirty="0"/>
-              <a:t>para la sociedad. D califica legítimamente bajo Art. 42 N°2 inc. 3° LIR.</a:t>
-            </a:r>
-          </a:p>
-        </p:txBody>
-      </p:sp>
-      <p:sp>
-        <p:nvSpPr>
-          <p:cNvPr id="114" name="Rect 114"/>
+            <a:pPr marL="114300" indent="-114300"/>
+            <a:r>
+              <a:rPr lang="es-CL" sz="1000" dirty="0"/>
+              <a:t>A se asocia con profesionales que efectivamente presten servicios para la sociedad. D califica legítimamente bajo Art. 42 N°2 inc. 3° LIR.</a:t>
+            </a:r>
+          </a:p>
+        </p:txBody>
+      </p:sp>
+      <p:sp>
+        <p:nvSpPr>
+          <p:cNvPr id="114" name="Rect114"/>
           <p:cNvSpPr/>
           <p:nvPr/>
         </p:nvSpPr>
         <p:spPr>
           <a:xfrm>
-            <a:off x="594360" y="3529584"/>
-            <a:ext cx="6428232" cy="320040"/>
+            <a:off x="457200" y="4133088"/>
+            <a:ext cx="6309360" cy="292608"/>
           </a:xfrm>
           <a:prstGeom prst="rect">
             <a:avLst/>
@@ -12928,78 +12858,64 @@
           </a:fontRef>
         </p:style>
         <p:txBody>
-          <a:bodyPr rtlCol="0" anchor="ctr"/>
+          <a:bodyPr rtlCol="0" anchor="ctr">
+            <a:normAutofit/>
+          </a:bodyPr>
           <a:lstStyle/>
           <a:p>
             <a:r>
               <a:rPr lang="es-CL" sz="1100" dirty="0">
                 <a:b>1</a:b>
               </a:rPr>
-              <a:t>Alt. 3 — Distribución de utilidades proporcional al trabajo real</a:t>
-            </a:r>
-          </a:p>
-        </p:txBody>
-      </p:sp>
-      <p:sp>
-        <p:nvSpPr>
-          <p:cNvPr id="115" name="AltDesc2"/>
+              <a:t>Alt. 3 — Distribución proporcional al trabajo real</a:t>
+            </a:r>
+          </a:p>
+        </p:txBody>
+      </p:sp>
+      <p:sp>
+        <p:nvSpPr>
+          <p:cNvPr id="115" name="Desc115"/>
           <p:cNvSpPr/>
           <p:nvPr/>
         </p:nvSpPr>
         <p:spPr>
           <a:xfrm>
-            <a:off x="594360" y="3849624"/>
-            <a:ext cx="6428232" cy="429768"/>
+            <a:off x="457200" y="4425696"/>
+            <a:ext cx="6309360" cy="475488"/>
           </a:xfrm>
           <a:prstGeom prst="rect">
             <a:avLst/>
           </a:prstGeom>
-        </p:spPr>
-        <p:style>
-          <a:lnRef idx="2">
-            <a:schemeClr val="accent1">
-              <a:shade val="50000"/>
-            </a:schemeClr>
-          </a:lnRef>
-          <a:fillRef idx="2">
+          <a:solidFill>
             <a:schemeClr val="accent1">
               <a:tint val="20000"/>
             </a:schemeClr>
-          </a:fillRef>
-          <a:effectRef idx="0">
-            <a:schemeClr val="accent1"/>
-          </a:effectRef>
-          <a:fontRef idx="minor">
-            <a:schemeClr val="dk1"/>
-          </a:fontRef>
-        </p:style>
-        <p:txBody>
-          <a:bodyPr rtlCol="0" anchor="ctr"/>
+          </a:solidFill>
+        </p:spPr>
+        <p:txBody>
+          <a:bodyPr rtlCol="0" anchor="ctr">
+            <a:normAutofit/>
+          </a:bodyPr>
           <a:lstStyle/>
           <a:p>
-            <a:r>
-              <a:rPr lang="es-CL" sz="950" dirty="0"/>
-              <a:t>Estatutos contemplan participación diferenciada acorde al aporte efectivo</a:t>
-            </a:r>
-          </a:p>
-          <a:p>
-            <a:r>
-              <a:rPr lang="es-CL" sz="950" dirty="0"/>
-              <a:t>o sueldo patronal previo al reparto. Debe reflejar la realidad económica.</a:t>
-            </a:r>
-          </a:p>
-        </p:txBody>
-      </p:sp>
-      <p:sp>
-        <p:nvSpPr>
-          <p:cNvPr id="116" name="Rect 116"/>
+            <a:pPr marL="114300" indent="-114300"/>
+            <a:r>
+              <a:rPr lang="es-CL" sz="1000" dirty="0"/>
+              <a:t>Estatutos con participación diferenciada (ej. A 90%, B 5%, C 5%) o sueldo patronal previo al reparto. La distribución debe reflejar el aporte efectivo de cada socio.</a:t>
+            </a:r>
+          </a:p>
+        </p:txBody>
+      </p:sp>
+      <p:sp>
+        <p:nvSpPr>
+          <p:cNvPr id="116" name="Rect116"/>
           <p:cNvSpPr/>
           <p:nvPr/>
         </p:nvSpPr>
         <p:spPr>
           <a:xfrm>
-            <a:off x="594360" y="4334256"/>
-            <a:ext cx="6428232" cy="320040"/>
+            <a:off x="457200" y="4956048"/>
+            <a:ext cx="6309360" cy="292608"/>
           </a:xfrm>
           <a:prstGeom prst="rect">
             <a:avLst/>
@@ -13022,7 +12938,9 @@
           </a:fontRef>
         </p:style>
         <p:txBody>
-          <a:bodyPr rtlCol="0" anchor="ctr"/>
+          <a:bodyPr rtlCol="0" anchor="ctr">
+            <a:normAutofit/>
+          </a:bodyPr>
           <a:lstStyle/>
           <a:p>
             <a:r>
@@ -13036,64 +12954,48 @@
       </p:sp>
       <p:sp>
         <p:nvSpPr>
-          <p:cNvPr id="117" name="AltDesc3"/>
+          <p:cNvPr id="117" name="Desc117"/>
           <p:cNvSpPr/>
           <p:nvPr/>
         </p:nvSpPr>
         <p:spPr>
           <a:xfrm>
-            <a:off x="594360" y="4654296"/>
-            <a:ext cx="6428232" cy="429768"/>
+            <a:off x="457200" y="5248656"/>
+            <a:ext cx="6309360" cy="475488"/>
           </a:xfrm>
           <a:prstGeom prst="rect">
             <a:avLst/>
           </a:prstGeom>
-        </p:spPr>
-        <p:style>
-          <a:lnRef idx="2">
-            <a:schemeClr val="accent1">
-              <a:shade val="50000"/>
-            </a:schemeClr>
-          </a:lnRef>
-          <a:fillRef idx="2">
+          <a:solidFill>
             <a:schemeClr val="accent1">
               <a:tint val="20000"/>
             </a:schemeClr>
-          </a:fillRef>
-          <a:effectRef idx="0">
-            <a:schemeClr val="accent1"/>
-          </a:effectRef>
-          <a:fontRef idx="minor">
-            <a:schemeClr val="dk1"/>
-          </a:fontRef>
-        </p:style>
-        <p:txBody>
-          <a:bodyPr rtlCol="0" anchor="ctr"/>
+          </a:solidFill>
+        </p:spPr>
+        <p:txBody>
+          <a:bodyPr rtlCol="0" anchor="ctr">
+            <a:normAutofit/>
+          </a:bodyPr>
           <a:lstStyle/>
           <a:p>
-            <a:r>
-              <a:rPr lang="es-CL" sz="950" dirty="0"/>
-              <a:t>SpA con IDPC al 25%. Permite planificación de retiros y reinversión.</a:t>
-            </a:r>
-          </a:p>
-          <a:p>
-            <a:r>
-              <a:rPr lang="es-CL" sz="950" dirty="0"/>
-              <a:t>Sin restricciones de la sociedad de profesionales. Exige sustancia real.</a:t>
-            </a:r>
-          </a:p>
-        </p:txBody>
-      </p:sp>
-      <p:sp>
-        <p:nvSpPr>
-          <p:cNvPr id="118" name="Rect 118"/>
+            <a:pPr marL="114300" indent="-114300"/>
+            <a:r>
+              <a:rPr lang="es-CL" sz="1000" dirty="0"/>
+              <a:t>SpA con IDPC al 25%. Permite planificación de retiros y reinversión. No tiene las restricciones de la sociedad de profesionales, pero exige sustancia económica real.</a:t>
+            </a:r>
+          </a:p>
+        </p:txBody>
+      </p:sp>
+      <p:sp>
+        <p:nvSpPr>
+          <p:cNvPr id="118" name="Rect118"/>
           <p:cNvSpPr/>
           <p:nvPr/>
         </p:nvSpPr>
         <p:spPr>
           <a:xfrm>
-            <a:off x="594360" y="5138927"/>
-            <a:ext cx="6428232" cy="320040"/>
+            <a:off x="457200" y="5779008"/>
+            <a:ext cx="6309360" cy="292608"/>
           </a:xfrm>
           <a:prstGeom prst="rect">
             <a:avLst/>
@@ -13116,7 +13018,9 @@
           </a:fontRef>
         </p:style>
         <p:txBody>
-          <a:bodyPr rtlCol="0" anchor="ctr"/>
+          <a:bodyPr rtlCol="0" anchor="ctr">
+            <a:normAutofit/>
+          </a:bodyPr>
           <a:lstStyle/>
           <a:p>
             <a:r>
@@ -13130,50 +13034,34 @@
       </p:sp>
       <p:sp>
         <p:nvSpPr>
-          <p:cNvPr id="119" name="AltDesc4"/>
+          <p:cNvPr id="119" name="Desc119"/>
           <p:cNvSpPr/>
           <p:nvPr/>
         </p:nvSpPr>
         <p:spPr>
           <a:xfrm>
-            <a:off x="594360" y="5458967"/>
-            <a:ext cx="6428232" cy="429768"/>
+            <a:off x="457200" y="6071616"/>
+            <a:ext cx="6309360" cy="475488"/>
           </a:xfrm>
           <a:prstGeom prst="rect">
             <a:avLst/>
           </a:prstGeom>
-        </p:spPr>
-        <p:style>
-          <a:lnRef idx="2">
-            <a:schemeClr val="accent1">
-              <a:shade val="50000"/>
-            </a:schemeClr>
-          </a:lnRef>
-          <a:fillRef idx="2">
+          <a:solidFill>
             <a:schemeClr val="accent1">
               <a:tint val="20000"/>
             </a:schemeClr>
-          </a:fillRef>
-          <a:effectRef idx="0">
-            <a:schemeClr val="accent1"/>
-          </a:effectRef>
-          <a:fontRef idx="minor">
-            <a:schemeClr val="dk1"/>
-          </a:fontRef>
-        </p:style>
-        <p:txBody>
-          <a:bodyPr rtlCol="0" anchor="ctr"/>
+          </a:solidFill>
+        </p:spPr>
+        <p:txBody>
+          <a:bodyPr rtlCol="0" anchor="ctr">
+            <a:normAutofit/>
+          </a:bodyPr>
           <a:lstStyle/>
           <a:p>
-            <a:r>
-              <a:rPr lang="es-CL" sz="950" dirty="0"/>
-              <a:t>La empresa no paga IDPC; socios tributan con IGC. SOLO válido si B y C</a:t>
-            </a:r>
-          </a:p>
-          <a:p>
-            <a:r>
-              <a:rPr lang="es-CL" sz="950" dirty="0"/>
-              <a:t>tienen sustancia económica real — de lo contrario el SII aplica NGA.</a:t>
+            <a:pPr marL="114300" indent="-114300"/>
+            <a:r>
+              <a:rPr lang="es-CL" sz="1000" dirty="0"/>
+              <a:t>La empresa no paga IDPC; socios tributan con IGC directo. Válido solo si B y C aportan sustancia real — de lo contrario el SII igualmente puede aplicar las NGA.</a:t>
             </a:r>
           </a:p>
         </p:txBody>
@@ -13238,78 +13126,34 @@
       </p:sp>
       <p:sp>
         <p:nvSpPr>
-          <p:cNvPr id="200" name="Header8"/>
-          <p:cNvSpPr>
-            <a:spLocks noGrp="1"/>
-          </p:cNvSpPr>
-          <p:nvPr>
-            <p:ph type="body" idx="1"/>
-          </p:nvPr>
-        </p:nvSpPr>
-        <p:spPr>
-          <a:xfrm>
-            <a:off x="594360" y="1362456"/>
-            <a:ext cx="6428232" cy="502920"/>
-          </a:xfrm>
-          <a:solidFill>
-            <a:schemeClr val="tx1">
-              <a:alpha val="74000"/>
-            </a:schemeClr>
-          </a:solidFill>
-        </p:spPr>
-        <p:txBody>
-          <a:bodyPr/>
-          <a:lstStyle/>
-          <a:p>
-            <a:r>
-              <a:rPr lang="es-CL" dirty="0">
-                <a:solidFill>
-                  <a:srgbClr val="FFC000"/>
-                </a:solidFill>
-              </a:rPr>
-              <a:t>Síntesis del análisis</a:t>
-            </a:r>
-          </a:p>
-        </p:txBody>
-      </p:sp>
-      <p:sp>
-        <p:nvSpPr>
-          <p:cNvPr id="201" name="PanelOscuro 201"/>
+          <p:cNvPr id="200" name="Panel200"/>
           <p:cNvSpPr/>
           <p:nvPr/>
         </p:nvSpPr>
         <p:spPr>
           <a:xfrm>
-            <a:off x="7132320" y="1362456"/>
-            <a:ext cx="4462272" cy="5047488"/>
+            <a:off x="6858000" y="2029968"/>
+            <a:ext cx="5120640" cy="4626864"/>
           </a:xfrm>
           <a:prstGeom prst="rect">
             <a:avLst/>
           </a:prstGeom>
           <a:gradFill>
             <a:gsLst>
-              <a:gs pos="73000">
+              <a:gs pos="0">
                 <a:schemeClr val="dk1">
-                  <a:tint val="60000"/>
+                  <a:tint val="55000"/>
                   <a:satMod val="105000"/>
-                  <a:lumMod val="105000"/>
-                </a:schemeClr>
-              </a:gs>
-              <a:gs pos="100000">
-                <a:schemeClr val="dk1">
-                  <a:tint val="65000"/>
-                  <a:satMod val="100000"/>
-                  <a:lumMod val="100000"/>
                 </a:schemeClr>
               </a:gs>
               <a:gs pos="100000">
                 <a:schemeClr val="dk1">
                   <a:tint val="70000"/>
                   <a:satMod val="100000"/>
-                  <a:lumMod val="100000"/>
                 </a:schemeClr>
               </a:gs>
             </a:gsLst>
+            <a:lin ang="5400000" scaled="0"/>
           </a:gradFill>
         </p:spPr>
         <p:style>
@@ -13327,7 +13171,7 @@
           </a:fontRef>
         </p:style>
         <p:txBody>
-          <a:bodyPr rtlCol="0" anchor="ctr"/>
+          <a:bodyPr/>
           <a:lstStyle/>
           <a:p>
             <a:endParaRPr lang="es-CL" dirty="0"/>
@@ -13336,14 +13180,14 @@
       </p:sp>
       <p:sp>
         <p:nvSpPr>
-          <p:cNvPr id="202" name="TB 202"/>
+          <p:cNvPr id="201" name="TB201"/>
           <p:cNvSpPr txBox="1"/>
           <p:nvPr/>
         </p:nvSpPr>
         <p:spPr>
           <a:xfrm>
-            <a:off x="7242048" y="1453896"/>
-            <a:ext cx="4242816" cy="411480"/>
+            <a:off x="6986016" y="2139696"/>
+            <a:ext cx="4864607" cy="2560320"/>
           </a:xfrm>
           <a:prstGeom prst="rect">
             <a:avLst/>
@@ -13351,45 +13195,26 @@
           <a:noFill/>
         </p:spPr>
         <p:txBody>
-          <a:bodyPr wrap="square" rtlCol="0"/>
+          <a:bodyPr wrap="square" rtlCol="0">
+            <a:normAutofit/>
+          </a:bodyPr>
           <a:lstStyle/>
           <a:p>
-            <a:pPr algn="ctr"/>
-            <a:r>
-              <a:rPr lang="es-CL" sz="1300" dirty="0">
+            <a:r>
+              <a:rPr lang="es-CL" sz="1200" b="1" dirty="0">
                 <a:solidFill>
                   <a:srgbClr val="FFC000"/>
                 </a:solidFill>
-                <a:b>1</a:b>
               </a:rPr>
               <a:t>Posición del Grupo 4</a:t>
             </a:r>
           </a:p>
-        </p:txBody>
-      </p:sp>
-      <p:sp>
-        <p:nvSpPr>
-          <p:cNvPr id="203" name="TB 203"/>
-          <p:cNvSpPr txBox="1"/>
-          <p:nvPr/>
-        </p:nvSpPr>
-        <p:spPr>
-          <a:xfrm>
-            <a:off x="7242048" y="1911095"/>
-            <a:ext cx="4242816" cy="2286000"/>
-          </a:xfrm>
-          <a:prstGeom prst="rect">
-            <a:avLst/>
-          </a:prstGeom>
-          <a:noFill/>
-        </p:spPr>
-        <p:txBody>
-          <a:bodyPr wrap="square" rtlCol="0"/>
-          <a:lstStyle/>
-          <a:p>
-            <a:pPr algn="l"/>
-            <a:r>
-              <a:rPr lang="es-CL" sz="1000" dirty="0">
+          <a:p>
+            <a:endParaRPr lang="es-CL" sz="600" dirty="0"/>
+          </a:p>
+          <a:p>
+            <a:r>
+              <a:rPr lang="es-CL" sz="980" dirty="0">
                 <a:solidFill>
                   <a:srgbClr val="FFFFFF"/>
                 </a:solidFill>
@@ -13398,20 +13223,18 @@
             </a:r>
           </a:p>
           <a:p>
-            <a:pPr algn="l"/>
-            <a:r>
-              <a:rPr lang="es-CL" sz="1000" dirty="0">
+            <a:r>
+              <a:rPr lang="es-CL" sz="980" dirty="0">
                 <a:solidFill>
                   <a:srgbClr val="FFFFFF"/>
                 </a:solidFill>
               </a:rPr>
-              <a:t>las formas jurídicas (Art. 4 ter CT).</a:t>
-            </a:r>
-          </a:p>
-          <a:p>
-            <a:pPr algn="l"/>
-            <a:r>
-              <a:rPr lang="es-CL" sz="1000" dirty="0">
+              <a:t>formas jurídicas (Art. 4 ter CT).</a:t>
+            </a:r>
+          </a:p>
+          <a:p>
+            <a:r>
+              <a:rPr lang="es-CL" sz="980" dirty="0">
                 <a:solidFill>
                   <a:srgbClr val="FFFFFF"/>
                 </a:solidFill>
@@ -13420,9 +13243,8 @@
             </a:r>
           </a:p>
           <a:p>
-            <a:pPr algn="l"/>
-            <a:r>
-              <a:rPr lang="es-CL" sz="1000" dirty="0">
+            <a:r>
+              <a:rPr lang="es-CL" sz="980" dirty="0">
                 <a:solidFill>
                   <a:srgbClr val="FFFFFF"/>
                 </a:solidFill>
@@ -13431,9 +13253,8 @@
             </a:r>
           </a:p>
           <a:p>
-            <a:pPr algn="l"/>
-            <a:r>
-              <a:rPr lang="es-CL" sz="1000" dirty="0">
+            <a:r>
+              <a:rPr lang="es-CL" sz="980" dirty="0">
                 <a:solidFill>
                   <a:srgbClr val="FFFFFF"/>
                 </a:solidFill>
@@ -13442,31 +13263,28 @@
             </a:r>
           </a:p>
           <a:p>
-            <a:pPr algn="l"/>
-            <a:r>
-              <a:rPr lang="es-CL" sz="1000" dirty="0">
+            <a:r>
+              <a:rPr lang="es-CL" sz="980" dirty="0">
                 <a:solidFill>
                   <a:srgbClr val="FFFFFF"/>
                 </a:solidFill>
               </a:rPr>
-              <a:t>inapropiada para el sustrato</a:t>
-            </a:r>
-          </a:p>
-          <a:p>
-            <a:pPr algn="l"/>
-            <a:r>
-              <a:rPr lang="es-CL" sz="1000" dirty="0">
+              <a:t>inapropiada — el único efecto</a:t>
+            </a:r>
+          </a:p>
+          <a:p>
+            <a:r>
+              <a:rPr lang="es-CL" sz="980" dirty="0">
                 <a:solidFill>
                   <a:srgbClr val="FFFFFF"/>
                 </a:solidFill>
               </a:rPr>
-              <a:t>económico del caso.</a:t>
-            </a:r>
-          </a:p>
-          <a:p>
-            <a:pPr algn="l"/>
-            <a:r>
-              <a:rPr lang="es-CL" sz="1000" dirty="0">
+              <a:t>relevante es tributario.</a:t>
+            </a:r>
+          </a:p>
+          <a:p>
+            <a:r>
+              <a:rPr lang="es-CL" sz="980" dirty="0">
                 <a:solidFill>
                   <a:srgbClr val="FFFFFF"/>
                 </a:solidFill>
@@ -13475,9 +13293,8 @@
             </a:r>
           </a:p>
           <a:p>
-            <a:pPr algn="l"/>
-            <a:r>
-              <a:rPr lang="es-CL" sz="1000" dirty="0">
+            <a:r>
+              <a:rPr lang="es-CL" sz="980" dirty="0">
                 <a:solidFill>
                   <a:srgbClr val="FFFFFF"/>
                 </a:solidFill>
@@ -13486,61 +13303,57 @@
             </a:r>
           </a:p>
           <a:p>
-            <a:pPr algn="l"/>
-            <a:r>
-              <a:rPr lang="es-CL" sz="1000" dirty="0">
+            <a:r>
+              <a:rPr lang="es-CL" sz="980" dirty="0">
                 <a:solidFill>
                   <a:srgbClr val="FFFFFF"/>
                 </a:solidFill>
               </a:rPr>
-              <a:t>▪  Andrea Añasco</a:t>
-            </a:r>
-          </a:p>
-          <a:p>
-            <a:pPr algn="l"/>
-            <a:r>
-              <a:rPr lang="es-CL" sz="1000" dirty="0">
+              <a:t>  Andrea Añasco</a:t>
+            </a:r>
+          </a:p>
+          <a:p>
+            <a:r>
+              <a:rPr lang="es-CL" sz="980" dirty="0">
                 <a:solidFill>
                   <a:srgbClr val="FFFFFF"/>
                 </a:solidFill>
               </a:rPr>
-              <a:t>▪  Gema Sepúlveda</a:t>
-            </a:r>
-          </a:p>
-          <a:p>
-            <a:pPr algn="l"/>
-            <a:r>
-              <a:rPr lang="es-CL" sz="1000" dirty="0">
+              <a:t>  Gema Sepúlveda</a:t>
+            </a:r>
+          </a:p>
+          <a:p>
+            <a:r>
+              <a:rPr lang="es-CL" sz="980" dirty="0">
                 <a:solidFill>
                   <a:srgbClr val="FFFFFF"/>
                 </a:solidFill>
               </a:rPr>
-              <a:t>▪  Karen Rebolledo</a:t>
-            </a:r>
-          </a:p>
-          <a:p>
-            <a:pPr algn="l"/>
-            <a:r>
-              <a:rPr lang="es-CL" sz="1000" dirty="0">
+              <a:t>  Karen Rebolledo</a:t>
+            </a:r>
+          </a:p>
+          <a:p>
+            <a:r>
+              <a:rPr lang="es-CL" sz="980" dirty="0">
                 <a:solidFill>
                   <a:srgbClr val="FFFFFF"/>
                 </a:solidFill>
               </a:rPr>
-              <a:t>▪  Nicolás Muñoz</a:t>
-            </a:r>
-          </a:p>
-        </p:txBody>
-      </p:sp>
-      <p:sp>
-        <p:nvSpPr>
-          <p:cNvPr id="204" name="TB 204"/>
+              <a:t>  Nicolás Muñoz</a:t>
+            </a:r>
+          </a:p>
+        </p:txBody>
+      </p:sp>
+      <p:sp>
+        <p:nvSpPr>
+          <p:cNvPr id="202" name="TB202"/>
           <p:cNvSpPr txBox="1"/>
           <p:nvPr/>
         </p:nvSpPr>
         <p:spPr>
           <a:xfrm>
-            <a:off x="7242048" y="4334256"/>
-            <a:ext cx="4242816" cy="411480"/>
+            <a:off x="6986016" y="4818888"/>
+            <a:ext cx="4864607" cy="1737360"/>
           </a:xfrm>
           <a:prstGeom prst="rect">
             <a:avLst/>
@@ -13548,108 +13361,120 @@
           <a:noFill/>
         </p:spPr>
         <p:txBody>
-          <a:bodyPr wrap="square" rtlCol="0"/>
+          <a:bodyPr wrap="square" rtlCol="0">
+            <a:normAutofit/>
+          </a:bodyPr>
           <a:lstStyle/>
           <a:p>
-            <a:pPr algn="ctr"/>
-            <a:r>
-              <a:rPr lang="es-CL" sz="1200" dirty="0">
+            <a:r>
+              <a:rPr lang="es-CL" sz="1200" b="1" dirty="0">
                 <a:solidFill>
                   <a:srgbClr val="FFC000"/>
                 </a:solidFill>
-                <a:b>1</a:b>
               </a:rPr>
-              <a:t>Norma aplicable</a:t>
-            </a:r>
-          </a:p>
-        </p:txBody>
-      </p:sp>
-      <p:sp>
-        <p:nvSpPr>
-          <p:cNvPr id="205" name="TB 205"/>
-          <p:cNvSpPr txBox="1"/>
-          <p:nvPr/>
-        </p:nvSpPr>
-        <p:spPr>
-          <a:xfrm>
-            <a:off x="7242048" y="4791456"/>
-            <a:ext cx="4242816" cy="1508760"/>
-          </a:xfrm>
-          <a:prstGeom prst="rect">
-            <a:avLst/>
-          </a:prstGeom>
-          <a:noFill/>
-        </p:spPr>
-        <p:txBody>
-          <a:bodyPr wrap="square" rtlCol="0"/>
-          <a:lstStyle/>
-          <a:p>
-            <a:pPr algn="l"/>
-            <a:r>
-              <a:rPr lang="es-CL" sz="1000" dirty="0">
+              <a:t>Norma aplicada</a:t>
+            </a:r>
+          </a:p>
+          <a:p>
+            <a:endParaRPr lang="es-CL" sz="600" dirty="0"/>
+          </a:p>
+          <a:p>
+            <a:r>
+              <a:rPr lang="es-CL" sz="980" dirty="0">
                 <a:solidFill>
                   <a:srgbClr val="FFFFFF"/>
                 </a:solidFill>
               </a:rPr>
-              <a:t>▪  Art. 4 ter CT — ABUSO</a:t>
-            </a:r>
-          </a:p>
-          <a:p>
-            <a:pPr algn="l"/>
-            <a:r>
-              <a:rPr lang="es-CL" sz="1000" dirty="0">
+              <a:t>• Art. 4 ter CT — Abuso</a:t>
+            </a:r>
+          </a:p>
+          <a:p>
+            <a:r>
+              <a:rPr lang="es-CL" sz="980" dirty="0">
                 <a:solidFill>
                   <a:srgbClr val="FFFFFF"/>
                 </a:solidFill>
               </a:rPr>
-              <a:t>▪  Art. 4 quinquies CT — Procedimiento</a:t>
-            </a:r>
-          </a:p>
-          <a:p>
-            <a:pPr algn="l"/>
-            <a:r>
-              <a:rPr lang="es-CL" sz="1000" dirty="0">
+              <a:t>• Art. 4 quinquies CT — Procedimiento</a:t>
+            </a:r>
+          </a:p>
+          <a:p>
+            <a:r>
+              <a:rPr lang="es-CL" sz="980" dirty="0">
                 <a:solidFill>
                   <a:srgbClr val="FFFFFF"/>
                 </a:solidFill>
               </a:rPr>
-              <a:t>▪  Art. 42 N°2 LIR</a:t>
-            </a:r>
-          </a:p>
-          <a:p>
-            <a:pPr algn="l"/>
-            <a:r>
-              <a:rPr lang="es-CL" sz="1000" dirty="0">
+              <a:t>• Art. 42 N°2 LIR</a:t>
+            </a:r>
+          </a:p>
+          <a:p>
+            <a:r>
+              <a:rPr lang="es-CL" sz="980" dirty="0">
                 <a:solidFill>
                   <a:srgbClr val="FFFFFF"/>
                 </a:solidFill>
               </a:rPr>
-              <a:t>▪  Circ. N°21/1991 y N°50/2020 SII</a:t>
-            </a:r>
-          </a:p>
-          <a:p>
-            <a:pPr algn="l"/>
-            <a:r>
-              <a:rPr lang="es-CL" sz="1000" dirty="0">
+              <a:t>• Circ. N°21/1991 y N°50/2020 SII</a:t>
+            </a:r>
+          </a:p>
+          <a:p>
+            <a:r>
+              <a:rPr lang="es-CL" sz="980" dirty="0">
                 <a:solidFill>
                   <a:srgbClr val="FFFFFF"/>
                 </a:solidFill>
               </a:rPr>
-              <a:t>▪  Ley N°20.780 y N°21.210</a:t>
-            </a:r>
-          </a:p>
-        </p:txBody>
-      </p:sp>
-      <p:sp>
-        <p:nvSpPr>
-          <p:cNvPr id="210" name="Rect 210"/>
+              <a:t>• Ley N°20.780 y Ley N°21.210</a:t>
+            </a:r>
+          </a:p>
+        </p:txBody>
+      </p:sp>
+      <p:sp>
+        <p:nvSpPr>
+          <p:cNvPr id="203" name="Hdr203"/>
           <p:cNvSpPr/>
           <p:nvPr/>
         </p:nvSpPr>
         <p:spPr>
           <a:xfrm>
-            <a:off x="594360" y="1920240"/>
-            <a:ext cx="6428232" cy="320040"/>
+            <a:off x="457200" y="2029968"/>
+            <a:ext cx="6309360" cy="420624"/>
+          </a:xfrm>
+          <a:prstGeom prst="rect">
+            <a:avLst/>
+          </a:prstGeom>
+          <a:solidFill>
+            <a:schemeClr val="tx1">
+              <a:alpha val="82000"/>
+            </a:schemeClr>
+          </a:solidFill>
+        </p:spPr>
+        <p:txBody>
+          <a:bodyPr rtlCol="0" anchor="ctr"/>
+          <a:lstStyle/>
+          <a:p>
+            <a:r>
+              <a:rPr lang="es-CL" sz="1600" b="1" dirty="0">
+                <a:solidFill>
+                  <a:srgbClr val="FFC000"/>
+                </a:solidFill>
+              </a:rPr>
+              <a:t>Síntesis del análisis — Caso 86</a:t>
+            </a:r>
+          </a:p>
+        </p:txBody>
+      </p:sp>
+      <p:sp>
+        <p:nvSpPr>
+          <p:cNvPr id="210" name="Rect210"/>
+          <p:cNvSpPr/>
+          <p:nvPr/>
+        </p:nvSpPr>
+        <p:spPr>
+          <a:xfrm>
+            <a:off x="457200" y="2487168"/>
+            <a:ext cx="6309360" cy="292608"/>
           </a:xfrm>
           <a:prstGeom prst="rect">
             <a:avLst/>
@@ -13672,78 +13497,64 @@
           </a:fontRef>
         </p:style>
         <p:txBody>
-          <a:bodyPr rtlCol="0" anchor="ctr"/>
+          <a:bodyPr rtlCol="0" anchor="ctr">
+            <a:normAutofit/>
+          </a:bodyPr>
           <a:lstStyle/>
           <a:p>
             <a:r>
               <a:rPr lang="es-CL" sz="1100" dirty="0">
                 <a:b>1</a:b>
               </a:rPr>
-              <a:t>ABUSO de formas jurídicas — Art. 4 ter CT</a:t>
-            </a:r>
-          </a:p>
-        </p:txBody>
-      </p:sp>
-      <p:sp>
-        <p:nvSpPr>
-          <p:cNvPr id="211" name="ConcDesc0"/>
+              <a:t>1. ABUSO de formas jurídicas — Art. 4 ter CT</a:t>
+            </a:r>
+          </a:p>
+        </p:txBody>
+      </p:sp>
+      <p:sp>
+        <p:nvSpPr>
+          <p:cNvPr id="211" name="Desc211"/>
           <p:cNvSpPr/>
           <p:nvPr/>
         </p:nvSpPr>
         <p:spPr>
           <a:xfrm>
-            <a:off x="594360" y="2240280"/>
-            <a:ext cx="6428232" cy="429768"/>
+            <a:off x="457200" y="2779776"/>
+            <a:ext cx="6309360" cy="475488"/>
           </a:xfrm>
           <a:prstGeom prst="rect">
             <a:avLst/>
           </a:prstGeom>
-        </p:spPr>
-        <p:style>
-          <a:lnRef idx="2">
-            <a:schemeClr val="accent1">
-              <a:shade val="50000"/>
-            </a:schemeClr>
-          </a:lnRef>
-          <a:fillRef idx="2">
+          <a:solidFill>
             <a:schemeClr val="accent1">
               <a:tint val="20000"/>
             </a:schemeClr>
-          </a:fillRef>
-          <a:effectRef idx="0">
-            <a:schemeClr val="accent1"/>
-          </a:effectRef>
-          <a:fontRef idx="minor">
-            <a:schemeClr val="dk1"/>
-          </a:fontRef>
-        </p:style>
-        <p:txBody>
-          <a:bodyPr rtlCol="0" anchor="ctr"/>
+          </a:solidFill>
+        </p:spPr>
+        <p:txBody>
+          <a:bodyPr rtlCol="0" anchor="ctr">
+            <a:normAutofit/>
+          </a:bodyPr>
           <a:lstStyle/>
           <a:p>
-            <a:r>
-              <a:rPr lang="es-CL" sz="950" dirty="0"/>
-              <a:t>El esquema utiliza una forma jurídica inapropiada para el sustrato económico.</a:t>
-            </a:r>
-          </a:p>
-          <a:p>
-            <a:r>
-              <a:rPr lang="es-CL" sz="950" dirty="0"/>
-              <a:t>Los actos son reales pero el único efecto relevante es tributario.</a:t>
-            </a:r>
-          </a:p>
-        </p:txBody>
-      </p:sp>
-      <p:sp>
-        <p:nvSpPr>
-          <p:cNvPr id="212" name="Rect 212"/>
+            <a:pPr marL="114300" indent="-114300"/>
+            <a:r>
+              <a:rPr lang="es-CL" sz="1000" dirty="0"/>
+              <a:t>El esquema usa la figura de sociedad de profesionales de forma inapropiada. Los actos son reales, pero el único efecto relevante distinto del tributario es ninguno.</a:t>
+            </a:r>
+          </a:p>
+        </p:txBody>
+      </p:sp>
+      <p:sp>
+        <p:nvSpPr>
+          <p:cNvPr id="212" name="Rect212"/>
           <p:cNvSpPr/>
           <p:nvPr/>
         </p:nvSpPr>
         <p:spPr>
           <a:xfrm>
-            <a:off x="594360" y="2724912"/>
-            <a:ext cx="6428232" cy="320040"/>
+            <a:off x="457200" y="3310128"/>
+            <a:ext cx="6309360" cy="292608"/>
           </a:xfrm>
           <a:prstGeom prst="rect">
             <a:avLst/>
@@ -13766,78 +13577,64 @@
           </a:fontRef>
         </p:style>
         <p:txBody>
-          <a:bodyPr rtlCol="0" anchor="ctr"/>
+          <a:bodyPr rtlCol="0" anchor="ctr">
+            <a:normAutofit/>
+          </a:bodyPr>
           <a:lstStyle/>
           <a:p>
             <a:r>
               <a:rPr lang="es-CL" sz="1100" dirty="0">
                 <a:b>1</a:b>
               </a:rPr>
-              <a:t>La sociedad D NO califica como sociedad de profesionales</a:t>
-            </a:r>
-          </a:p>
-        </p:txBody>
-      </p:sp>
-      <p:sp>
-        <p:nvSpPr>
-          <p:cNvPr id="213" name="ConcDesc1"/>
+              <a:t>2. La sociedad D no califica como sociedad de profesionales</a:t>
+            </a:r>
+          </a:p>
+        </p:txBody>
+      </p:sp>
+      <p:sp>
+        <p:nvSpPr>
+          <p:cNvPr id="213" name="Desc213"/>
           <p:cNvSpPr/>
           <p:nvPr/>
         </p:nvSpPr>
         <p:spPr>
           <a:xfrm>
-            <a:off x="594360" y="3044952"/>
-            <a:ext cx="6428232" cy="429768"/>
+            <a:off x="457200" y="3602736"/>
+            <a:ext cx="6309360" cy="475488"/>
           </a:xfrm>
           <a:prstGeom prst="rect">
             <a:avLst/>
           </a:prstGeom>
-        </p:spPr>
-        <p:style>
-          <a:lnRef idx="2">
-            <a:schemeClr val="accent1">
-              <a:shade val="50000"/>
-            </a:schemeClr>
-          </a:lnRef>
-          <a:fillRef idx="2">
+          <a:solidFill>
             <a:schemeClr val="accent1">
               <a:tint val="20000"/>
             </a:schemeClr>
-          </a:fillRef>
-          <a:effectRef idx="0">
-            <a:schemeClr val="accent1"/>
-          </a:effectRef>
-          <a:fontRef idx="minor">
-            <a:schemeClr val="dk1"/>
-          </a:fontRef>
-        </p:style>
-        <p:txBody>
-          <a:bodyPr rtlCol="0" anchor="ctr"/>
+          </a:solidFill>
+        </p:spPr>
+        <p:txBody>
+          <a:bodyPr rtlCol="0" anchor="ctr">
+            <a:normAutofit/>
+          </a:bodyPr>
           <a:lstStyle/>
           <a:p>
-            <a:r>
-              <a:rPr lang="es-CL" sz="950" dirty="0"/>
-              <a:t>B y C no ejercen su profesión para la sociedad, incumpliendo requisito</a:t>
-            </a:r>
-          </a:p>
-          <a:p>
-            <a:r>
-              <a:rPr lang="es-CL" sz="950" dirty="0"/>
-              <a:t>copulativo de las Circulares N°21/1991 y N°50/2020 del SII.</a:t>
-            </a:r>
-          </a:p>
-        </p:txBody>
-      </p:sp>
-      <p:sp>
-        <p:nvSpPr>
-          <p:cNvPr id="214" name="Rect 214"/>
+            <a:pPr marL="114300" indent="-114300"/>
+            <a:r>
+              <a:rPr lang="es-CL" sz="1000" dirty="0"/>
+              <a:t>B y C no ejercen su profesión para D, incumpliendo el requisito copulativo de las Circulares N°21/1991 y N°50/2020 del SII.</a:t>
+            </a:r>
+          </a:p>
+        </p:txBody>
+      </p:sp>
+      <p:sp>
+        <p:nvSpPr>
+          <p:cNvPr id="214" name="Rect214"/>
           <p:cNvSpPr/>
           <p:nvPr/>
         </p:nvSpPr>
         <p:spPr>
           <a:xfrm>
-            <a:off x="594360" y="3529584"/>
-            <a:ext cx="6428232" cy="320040"/>
+            <a:off x="457200" y="4133088"/>
+            <a:ext cx="6309360" cy="292608"/>
           </a:xfrm>
           <a:prstGeom prst="rect">
             <a:avLst/>
@@ -13860,78 +13657,64 @@
           </a:fontRef>
         </p:style>
         <p:txBody>
-          <a:bodyPr rtlCol="0" anchor="ctr"/>
+          <a:bodyPr rtlCol="0" anchor="ctr">
+            <a:normAutofit/>
+          </a:bodyPr>
           <a:lstStyle/>
           <a:p>
             <a:r>
               <a:rPr lang="es-CL" sz="1100" dirty="0">
                 <a:b>1</a:b>
               </a:rPr>
-              <a:t>El SII puede requerir declaración de abuso al TTA</a:t>
-            </a:r>
-          </a:p>
-        </p:txBody>
-      </p:sp>
-      <p:sp>
-        <p:nvSpPr>
-          <p:cNvPr id="215" name="ConcDesc2"/>
+              <a:t>3. El SII puede requerir declaración de abuso al TTA</a:t>
+            </a:r>
+          </a:p>
+        </p:txBody>
+      </p:sp>
+      <p:sp>
+        <p:nvSpPr>
+          <p:cNvPr id="215" name="Desc215"/>
           <p:cNvSpPr/>
           <p:nvPr/>
         </p:nvSpPr>
         <p:spPr>
           <a:xfrm>
-            <a:off x="594360" y="3849624"/>
-            <a:ext cx="6428232" cy="429768"/>
+            <a:off x="457200" y="4425696"/>
+            <a:ext cx="6309360" cy="475488"/>
           </a:xfrm>
           <a:prstGeom prst="rect">
             <a:avLst/>
           </a:prstGeom>
-        </p:spPr>
-        <p:style>
-          <a:lnRef idx="2">
-            <a:schemeClr val="accent1">
-              <a:shade val="50000"/>
-            </a:schemeClr>
-          </a:lnRef>
-          <a:fillRef idx="2">
+          <a:solidFill>
             <a:schemeClr val="accent1">
               <a:tint val="20000"/>
             </a:schemeClr>
-          </a:fillRef>
-          <a:effectRef idx="0">
-            <a:schemeClr val="accent1"/>
-          </a:effectRef>
-          <a:fontRef idx="minor">
-            <a:schemeClr val="dk1"/>
-          </a:fontRef>
-        </p:style>
-        <p:txBody>
-          <a:bodyPr rtlCol="0" anchor="ctr"/>
+          </a:solidFill>
+        </p:spPr>
+        <p:txBody>
+          <a:bodyPr rtlCol="0" anchor="ctr">
+            <a:normAutofit/>
+          </a:bodyPr>
           <a:lstStyle/>
           <a:p>
-            <a:r>
-              <a:rPr lang="es-CL" sz="950" dirty="0"/>
-              <a:t>Art. 4 quinquies CT: el Director puede solicitar al Tribunal Tributario y</a:t>
-            </a:r>
-          </a:p>
-          <a:p>
-            <a:r>
-              <a:rPr lang="es-CL" sz="950" dirty="0"/>
-              <a:t>Aduanero la declaración de abuso → recalificación + intereses + multas.</a:t>
-            </a:r>
-          </a:p>
-        </p:txBody>
-      </p:sp>
-      <p:sp>
-        <p:nvSpPr>
-          <p:cNvPr id="216" name="Rect 216"/>
+            <a:pPr marL="114300" indent="-114300"/>
+            <a:r>
+              <a:rPr lang="es-CL" sz="1000" dirty="0"/>
+              <a:t>Art. 4 quinquies CT: el Director del SII puede pedir al Tribunal Tributario y Aduanero la declaración de abuso → recalificación + intereses + multas.</a:t>
+            </a:r>
+          </a:p>
+        </p:txBody>
+      </p:sp>
+      <p:sp>
+        <p:nvSpPr>
+          <p:cNvPr id="216" name="Rect216"/>
           <p:cNvSpPr/>
           <p:nvPr/>
         </p:nvSpPr>
         <p:spPr>
           <a:xfrm>
-            <a:off x="594360" y="4334256"/>
-            <a:ext cx="6428232" cy="320040"/>
+            <a:off x="457200" y="4956048"/>
+            <a:ext cx="6309360" cy="292608"/>
           </a:xfrm>
           <a:prstGeom prst="rect">
             <a:avLst/>
@@ -13954,78 +13737,64 @@
           </a:fontRef>
         </p:style>
         <p:txBody>
-          <a:bodyPr rtlCol="0" anchor="ctr"/>
+          <a:bodyPr rtlCol="0" anchor="ctr">
+            <a:normAutofit/>
+          </a:bodyPr>
           <a:lstStyle/>
           <a:p>
             <a:r>
               <a:rPr lang="es-CL" sz="1100" dirty="0">
                 <a:b>1</a:b>
               </a:rPr>
-              <a:t>Existen alternativas legítimas de organización</a:t>
-            </a:r>
-          </a:p>
-        </p:txBody>
-      </p:sp>
-      <p:sp>
-        <p:nvSpPr>
-          <p:cNvPr id="217" name="ConcDesc3"/>
+              <a:t>4. Existen alternativas legítimas de organización</a:t>
+            </a:r>
+          </a:p>
+        </p:txBody>
+      </p:sp>
+      <p:sp>
+        <p:nvSpPr>
+          <p:cNvPr id="217" name="Desc217"/>
           <p:cNvSpPr/>
           <p:nvPr/>
         </p:nvSpPr>
         <p:spPr>
           <a:xfrm>
-            <a:off x="594360" y="4654296"/>
-            <a:ext cx="6428232" cy="429768"/>
+            <a:off x="457200" y="5248656"/>
+            <a:ext cx="6309360" cy="475488"/>
           </a:xfrm>
           <a:prstGeom prst="rect">
             <a:avLst/>
           </a:prstGeom>
-        </p:spPr>
-        <p:style>
-          <a:lnRef idx="2">
-            <a:schemeClr val="accent1">
-              <a:shade val="50000"/>
-            </a:schemeClr>
-          </a:lnRef>
-          <a:fillRef idx="2">
+          <a:solidFill>
             <a:schemeClr val="accent1">
               <a:tint val="20000"/>
             </a:schemeClr>
-          </a:fillRef>
-          <a:effectRef idx="0">
-            <a:schemeClr val="accent1"/>
-          </a:effectRef>
-          <a:fontRef idx="minor">
-            <a:schemeClr val="dk1"/>
-          </a:fontRef>
-        </p:style>
-        <p:txBody>
-          <a:bodyPr rtlCol="0" anchor="ctr"/>
+          </a:solidFill>
+        </p:spPr>
+        <p:txBody>
+          <a:bodyPr rtlCol="0" anchor="ctr">
+            <a:normAutofit/>
+          </a:bodyPr>
           <a:lstStyle/>
           <a:p>
-            <a:r>
-              <a:rPr lang="es-CL" sz="950" dirty="0"/>
-              <a:t>Profesional independiente, sociedad de profesionales con socios reales,</a:t>
-            </a:r>
-          </a:p>
-          <a:p>
-            <a:r>
-              <a:rPr lang="es-CL" sz="950" dirty="0"/>
-              <a:t>SpA Pro Pyme (14 D N°3) o distribución proporcional al trabajo real.</a:t>
-            </a:r>
-          </a:p>
-        </p:txBody>
-      </p:sp>
-      <p:sp>
-        <p:nvSpPr>
-          <p:cNvPr id="218" name="Rect 218"/>
+            <a:pPr marL="114300" indent="-114300"/>
+            <a:r>
+              <a:rPr lang="es-CL" sz="1000" dirty="0"/>
+              <a:t>Profesional independiente, sociedad de profesionales con socios reales, SpA Pro Pyme (14 D N°3) o distribución de utilidades proporcional al trabajo.</a:t>
+            </a:r>
+          </a:p>
+        </p:txBody>
+      </p:sp>
+      <p:sp>
+        <p:nvSpPr>
+          <p:cNvPr id="218" name="Rect218"/>
           <p:cNvSpPr/>
           <p:nvPr/>
         </p:nvSpPr>
         <p:spPr>
           <a:xfrm>
-            <a:off x="594360" y="5138927"/>
-            <a:ext cx="6428232" cy="320040"/>
+            <a:off x="457200" y="5779008"/>
+            <a:ext cx="6309360" cy="292608"/>
           </a:xfrm>
           <a:prstGeom prst="rect">
             <a:avLst/>
@@ -14048,64 +13817,50 @@
           </a:fontRef>
         </p:style>
         <p:txBody>
-          <a:bodyPr rtlCol="0" anchor="ctr"/>
+          <a:bodyPr rtlCol="0" anchor="ctr">
+            <a:normAutofit/>
+          </a:bodyPr>
           <a:lstStyle/>
           <a:p>
             <a:r>
               <a:rPr lang="es-CL" sz="1100" dirty="0">
                 <a:b>1</a:b>
               </a:rPr>
-              <a:t>La clave es la sustancia económica</a:t>
-            </a:r>
-          </a:p>
-        </p:txBody>
-      </p:sp>
-      <p:sp>
-        <p:nvSpPr>
-          <p:cNvPr id="219" name="ConcDesc4"/>
+              <a:t>5. La clave: sustancia económica real</a:t>
+            </a:r>
+          </a:p>
+        </p:txBody>
+      </p:sp>
+      <p:sp>
+        <p:nvSpPr>
+          <p:cNvPr id="219" name="Desc219"/>
           <p:cNvSpPr/>
           <p:nvPr/>
         </p:nvSpPr>
         <p:spPr>
           <a:xfrm>
-            <a:off x="594360" y="5458967"/>
-            <a:ext cx="6428232" cy="429768"/>
+            <a:off x="457200" y="6071616"/>
+            <a:ext cx="6309360" cy="475488"/>
           </a:xfrm>
           <a:prstGeom prst="rect">
             <a:avLst/>
           </a:prstGeom>
-        </p:spPr>
-        <p:style>
-          <a:lnRef idx="2">
-            <a:schemeClr val="accent1">
-              <a:shade val="50000"/>
-            </a:schemeClr>
-          </a:lnRef>
-          <a:fillRef idx="2">
+          <a:solidFill>
             <a:schemeClr val="accent1">
               <a:tint val="20000"/>
             </a:schemeClr>
-          </a:fillRef>
-          <a:effectRef idx="0">
-            <a:schemeClr val="accent1"/>
-          </a:effectRef>
-          <a:fontRef idx="minor">
-            <a:schemeClr val="dk1"/>
-          </a:fontRef>
-        </p:style>
-        <p:txBody>
-          <a:bodyPr rtlCol="0" anchor="ctr"/>
+          </a:solidFill>
+        </p:spPr>
+        <p:txBody>
+          <a:bodyPr rtlCol="0" anchor="ctr">
+            <a:normAutofit/>
+          </a:bodyPr>
           <a:lstStyle/>
           <a:p>
-            <a:r>
-              <a:rPr lang="es-CL" sz="950" dirty="0"/>
-              <a:t>Toda estructura debe poder demostrar que los socios aportan trabajo, capital,</a:t>
-            </a:r>
-          </a:p>
-          <a:p>
-            <a:r>
-              <a:rPr lang="es-CL" sz="950" dirty="0"/>
-              <a:t>clientela o dirección real. La forma jurídica por sí sola no es suficiente.</a:t>
+            <a:pPr marL="114300" indent="-114300"/>
+            <a:r>
+              <a:rPr lang="es-CL" sz="1000" dirty="0"/>
+              <a:t>Toda estructura debe demostrar que los socios aportan trabajo, capital, clientela o dirección efectiva. La forma jurídica por sí sola no es suficiente frente a NGA.</a:t>
             </a:r>
           </a:p>
         </p:txBody>

</xml_diff>

<commit_message>
Fix design bugs in modern PPT: header z-order, person letters, percentages overlap, portada cards
- Remove send_back(bg) from header() so navy band renders on top (fixes white-on-white title)
- Fix person() letter color from same-as-fill to WHITE (fixes invisible B/A/C letters)
- Move slide 4 percentages from y=2.85 to y=1.82 (above person icons, no overlap)
- Move slide 5 percentages from y=3.85 to y=3.55 (above circle tops, no overlap)
- Change portada name cards from NAVY_LT to BLUE, tighten spacing to avoid blending with right stripe

https://claude.ai/code/session_01Wu4J5kMW3gnyas1BwZ5v9s
</commit_message>
<xml_diff>
--- a/Caso86_Presentacion.pptx
+++ b/Caso86_Presentacion.pptx
@@ -3508,14 +3508,14 @@
         </p:nvSpPr>
         <p:spPr>
           <a:xfrm>
-            <a:off x="548640" y="4343400"/>
-            <a:ext cx="2651760" cy="502920"/>
+            <a:off x="457200" y="4343400"/>
+            <a:ext cx="2606040" cy="502920"/>
           </a:xfrm>
           <a:prstGeom prst="roundRect">
             <a:avLst/>
           </a:prstGeom>
           <a:solidFill>
-            <a:srgbClr val="254E80"/>
+            <a:srgbClr val="2E7BC4"/>
           </a:solidFill>
           <a:ln>
             <a:noFill/>
@@ -3561,14 +3561,14 @@
         </p:nvSpPr>
         <p:spPr>
           <a:xfrm>
-            <a:off x="3337560" y="4343400"/>
-            <a:ext cx="2651760" cy="502920"/>
+            <a:off x="3172968" y="4343400"/>
+            <a:ext cx="2606040" cy="502920"/>
           </a:xfrm>
           <a:prstGeom prst="roundRect">
             <a:avLst/>
           </a:prstGeom>
           <a:solidFill>
-            <a:srgbClr val="254E80"/>
+            <a:srgbClr val="2E7BC4"/>
           </a:solidFill>
           <a:ln>
             <a:noFill/>
@@ -3614,14 +3614,14 @@
         </p:nvSpPr>
         <p:spPr>
           <a:xfrm>
-            <a:off x="6126479" y="4343400"/>
-            <a:ext cx="2651760" cy="502920"/>
+            <a:off x="5888736" y="4343400"/>
+            <a:ext cx="2606040" cy="502920"/>
           </a:xfrm>
           <a:prstGeom prst="roundRect">
             <a:avLst/>
           </a:prstGeom>
           <a:solidFill>
-            <a:srgbClr val="254E80"/>
+            <a:srgbClr val="2E7BC4"/>
           </a:solidFill>
           <a:ln>
             <a:noFill/>
@@ -3667,14 +3667,14 @@
         </p:nvSpPr>
         <p:spPr>
           <a:xfrm>
-            <a:off x="8915400" y="4343400"/>
-            <a:ext cx="2651760" cy="502920"/>
+            <a:off x="8604504" y="4343400"/>
+            <a:ext cx="2606040" cy="502920"/>
           </a:xfrm>
           <a:prstGeom prst="roundRect">
             <a:avLst/>
           </a:prstGeom>
           <a:solidFill>
-            <a:srgbClr val="254E80"/>
+            <a:srgbClr val="2E7BC4"/>
           </a:solidFill>
           <a:ln>
             <a:noFill/>
@@ -3767,50 +3767,6 @@
       <p:grpSpPr/>
       <p:sp>
         <p:nvSpPr>
-          <p:cNvPr id="5" name="Rectangle 4"/>
-          <p:cNvSpPr/>
-          <p:nvPr/>
-        </p:nvSpPr>
-        <p:spPr>
-          <a:xfrm>
-            <a:off x="0" y="0"/>
-            <a:ext cx="12191695" cy="1325880"/>
-          </a:xfrm>
-          <a:prstGeom prst="rect">
-            <a:avLst/>
-          </a:prstGeom>
-          <a:solidFill>
-            <a:srgbClr val="1A3A5C"/>
-          </a:solidFill>
-          <a:ln>
-            <a:noFill/>
-          </a:ln>
-          <a:effectLst/>
-        </p:spPr>
-        <p:style>
-          <a:lnRef idx="1">
-            <a:schemeClr val="accent1"/>
-          </a:lnRef>
-          <a:fillRef idx="3">
-            <a:schemeClr val="accent1"/>
-          </a:fillRef>
-          <a:effectRef idx="2">
-            <a:schemeClr val="accent1"/>
-          </a:effectRef>
-          <a:fontRef idx="minor">
-            <a:schemeClr val="lt1"/>
-          </a:fontRef>
-        </p:style>
-        <p:txBody>
-          <a:bodyPr rtlCol="0" anchor="ctr"/>
-          <a:lstStyle/>
-          <a:p>
-            <a:pPr algn="ctr"/>
-          </a:p>
-        </p:txBody>
-      </p:sp>
-      <p:sp>
-        <p:nvSpPr>
           <p:cNvPr id="2" name="Rectangle 1"/>
           <p:cNvSpPr/>
           <p:nvPr/>
@@ -3929,6 +3885,50 @@
               </a:rPr>
               <a:t>Grupo 4: Andrea Añasco · Gema Sepúlveda · Karen Rebolledo · Nicolás Muñoz   |   Caso 86 — Catálogo de Esquemas Tributarios SII 2025</a:t>
             </a:r>
+          </a:p>
+        </p:txBody>
+      </p:sp>
+      <p:sp>
+        <p:nvSpPr>
+          <p:cNvPr id="5" name="Rectangle 4"/>
+          <p:cNvSpPr/>
+          <p:nvPr/>
+        </p:nvSpPr>
+        <p:spPr>
+          <a:xfrm>
+            <a:off x="0" y="0"/>
+            <a:ext cx="12191695" cy="1325880"/>
+          </a:xfrm>
+          <a:prstGeom prst="rect">
+            <a:avLst/>
+          </a:prstGeom>
+          <a:solidFill>
+            <a:srgbClr val="1A3A5C"/>
+          </a:solidFill>
+          <a:ln>
+            <a:noFill/>
+          </a:ln>
+          <a:effectLst/>
+        </p:spPr>
+        <p:style>
+          <a:lnRef idx="1">
+            <a:schemeClr val="accent1"/>
+          </a:lnRef>
+          <a:fillRef idx="3">
+            <a:schemeClr val="accent1"/>
+          </a:fillRef>
+          <a:effectRef idx="2">
+            <a:schemeClr val="accent1"/>
+          </a:effectRef>
+          <a:fontRef idx="minor">
+            <a:schemeClr val="lt1"/>
+          </a:fontRef>
+        </p:style>
+        <p:txBody>
+          <a:bodyPr rtlCol="0" anchor="ctr"/>
+          <a:lstStyle/>
+          <a:p>
+            <a:pPr algn="ctr"/>
           </a:p>
         </p:txBody>
       </p:sp>
@@ -4689,50 +4689,6 @@
       <p:grpSpPr/>
       <p:sp>
         <p:nvSpPr>
-          <p:cNvPr id="5" name="Rectangle 4"/>
-          <p:cNvSpPr/>
-          <p:nvPr/>
-        </p:nvSpPr>
-        <p:spPr>
-          <a:xfrm>
-            <a:off x="0" y="0"/>
-            <a:ext cx="12191695" cy="1325880"/>
-          </a:xfrm>
-          <a:prstGeom prst="rect">
-            <a:avLst/>
-          </a:prstGeom>
-          <a:solidFill>
-            <a:srgbClr val="1A3A5C"/>
-          </a:solidFill>
-          <a:ln>
-            <a:noFill/>
-          </a:ln>
-          <a:effectLst/>
-        </p:spPr>
-        <p:style>
-          <a:lnRef idx="1">
-            <a:schemeClr val="accent1"/>
-          </a:lnRef>
-          <a:fillRef idx="3">
-            <a:schemeClr val="accent1"/>
-          </a:fillRef>
-          <a:effectRef idx="2">
-            <a:schemeClr val="accent1"/>
-          </a:effectRef>
-          <a:fontRef idx="minor">
-            <a:schemeClr val="lt1"/>
-          </a:fontRef>
-        </p:style>
-        <p:txBody>
-          <a:bodyPr rtlCol="0" anchor="ctr"/>
-          <a:lstStyle/>
-          <a:p>
-            <a:pPr algn="ctr"/>
-          </a:p>
-        </p:txBody>
-      </p:sp>
-      <p:sp>
-        <p:nvSpPr>
           <p:cNvPr id="2" name="Rectangle 1"/>
           <p:cNvSpPr/>
           <p:nvPr/>
@@ -4851,6 +4807,50 @@
               </a:rPr>
               <a:t>Grupo 4: Andrea Añasco · Gema Sepúlveda · Karen Rebolledo · Nicolás Muñoz   |   Caso 86 — Catálogo de Esquemas Tributarios SII 2025</a:t>
             </a:r>
+          </a:p>
+        </p:txBody>
+      </p:sp>
+      <p:sp>
+        <p:nvSpPr>
+          <p:cNvPr id="5" name="Rectangle 4"/>
+          <p:cNvSpPr/>
+          <p:nvPr/>
+        </p:nvSpPr>
+        <p:spPr>
+          <a:xfrm>
+            <a:off x="0" y="0"/>
+            <a:ext cx="12191695" cy="1325880"/>
+          </a:xfrm>
+          <a:prstGeom prst="rect">
+            <a:avLst/>
+          </a:prstGeom>
+          <a:solidFill>
+            <a:srgbClr val="1A3A5C"/>
+          </a:solidFill>
+          <a:ln>
+            <a:noFill/>
+          </a:ln>
+          <a:effectLst/>
+        </p:spPr>
+        <p:style>
+          <a:lnRef idx="1">
+            <a:schemeClr val="accent1"/>
+          </a:lnRef>
+          <a:fillRef idx="3">
+            <a:schemeClr val="accent1"/>
+          </a:fillRef>
+          <a:effectRef idx="2">
+            <a:schemeClr val="accent1"/>
+          </a:effectRef>
+          <a:fontRef idx="minor">
+            <a:schemeClr val="lt1"/>
+          </a:fontRef>
+        </p:style>
+        <p:txBody>
+          <a:bodyPr rtlCol="0" anchor="ctr"/>
+          <a:lstStyle/>
+          <a:p>
+            <a:pPr algn="ctr"/>
           </a:p>
         </p:txBody>
       </p:sp>
@@ -6219,50 +6219,6 @@
       <p:grpSpPr/>
       <p:sp>
         <p:nvSpPr>
-          <p:cNvPr id="5" name="Rectangle 4"/>
-          <p:cNvSpPr/>
-          <p:nvPr/>
-        </p:nvSpPr>
-        <p:spPr>
-          <a:xfrm>
-            <a:off x="0" y="0"/>
-            <a:ext cx="12191695" cy="1325880"/>
-          </a:xfrm>
-          <a:prstGeom prst="rect">
-            <a:avLst/>
-          </a:prstGeom>
-          <a:solidFill>
-            <a:srgbClr val="1A3A5C"/>
-          </a:solidFill>
-          <a:ln>
-            <a:noFill/>
-          </a:ln>
-          <a:effectLst/>
-        </p:spPr>
-        <p:style>
-          <a:lnRef idx="1">
-            <a:schemeClr val="accent1"/>
-          </a:lnRef>
-          <a:fillRef idx="3">
-            <a:schemeClr val="accent1"/>
-          </a:fillRef>
-          <a:effectRef idx="2">
-            <a:schemeClr val="accent1"/>
-          </a:effectRef>
-          <a:fontRef idx="minor">
-            <a:schemeClr val="lt1"/>
-          </a:fontRef>
-        </p:style>
-        <p:txBody>
-          <a:bodyPr rtlCol="0" anchor="ctr"/>
-          <a:lstStyle/>
-          <a:p>
-            <a:pPr algn="ctr"/>
-          </a:p>
-        </p:txBody>
-      </p:sp>
-      <p:sp>
-        <p:nvSpPr>
           <p:cNvPr id="2" name="Rectangle 1"/>
           <p:cNvSpPr/>
           <p:nvPr/>
@@ -6386,6 +6342,50 @@
       </p:sp>
       <p:sp>
         <p:nvSpPr>
+          <p:cNvPr id="5" name="Rectangle 4"/>
+          <p:cNvSpPr/>
+          <p:nvPr/>
+        </p:nvSpPr>
+        <p:spPr>
+          <a:xfrm>
+            <a:off x="0" y="0"/>
+            <a:ext cx="12191695" cy="1325880"/>
+          </a:xfrm>
+          <a:prstGeom prst="rect">
+            <a:avLst/>
+          </a:prstGeom>
+          <a:solidFill>
+            <a:srgbClr val="1A3A5C"/>
+          </a:solidFill>
+          <a:ln>
+            <a:noFill/>
+          </a:ln>
+          <a:effectLst/>
+        </p:spPr>
+        <p:style>
+          <a:lnRef idx="1">
+            <a:schemeClr val="accent1"/>
+          </a:lnRef>
+          <a:fillRef idx="3">
+            <a:schemeClr val="accent1"/>
+          </a:fillRef>
+          <a:effectRef idx="2">
+            <a:schemeClr val="accent1"/>
+          </a:effectRef>
+          <a:fontRef idx="minor">
+            <a:schemeClr val="lt1"/>
+          </a:fontRef>
+        </p:style>
+        <p:txBody>
+          <a:bodyPr rtlCol="0" anchor="ctr"/>
+          <a:lstStyle/>
+          <a:p>
+            <a:pPr algn="ctr"/>
+          </a:p>
+        </p:txBody>
+      </p:sp>
+      <p:sp>
+        <p:nvSpPr>
           <p:cNvPr id="6" name="Rectangle 5"/>
           <p:cNvSpPr/>
           <p:nvPr/>
@@ -7386,7 +7386,7 @@
             <a:r>
               <a:rPr sz="2000" b="1" i="0">
                 <a:solidFill>
-                  <a:srgbClr val="2E7BC4"/>
+                  <a:srgbClr val="FFFFFF"/>
                 </a:solidFill>
                 <a:latin typeface="Calibri"/>
               </a:rPr>
@@ -7509,7 +7509,7 @@
             <a:r>
               <a:rPr sz="2000" b="1" i="0">
                 <a:solidFill>
-                  <a:srgbClr val="1A3A5C"/>
+                  <a:srgbClr val="FFFFFF"/>
                 </a:solidFill>
                 <a:latin typeface="Calibri"/>
               </a:rPr>
@@ -7632,7 +7632,7 @@
             <a:r>
               <a:rPr sz="2000" b="1" i="0">
                 <a:solidFill>
-                  <a:srgbClr val="2E7BC4"/>
+                  <a:srgbClr val="FFFFFF"/>
                 </a:solidFill>
                 <a:latin typeface="Calibri"/>
               </a:rPr>
@@ -7754,7 +7754,7 @@
         </p:nvSpPr>
         <p:spPr>
           <a:xfrm>
-            <a:off x="7498079" y="2606040"/>
+            <a:off x="7498079" y="1664208"/>
             <a:ext cx="777240" cy="256032"/>
           </a:xfrm>
           <a:prstGeom prst="rect">
@@ -7789,7 +7789,7 @@
         </p:nvSpPr>
         <p:spPr>
           <a:xfrm>
-            <a:off x="8887967" y="2606040"/>
+            <a:off x="8887967" y="1664208"/>
             <a:ext cx="777240" cy="256032"/>
           </a:xfrm>
           <a:prstGeom prst="rect">
@@ -7824,7 +7824,7 @@
         </p:nvSpPr>
         <p:spPr>
           <a:xfrm>
-            <a:off x="10241280" y="2606040"/>
+            <a:off x="10241280" y="1664208"/>
             <a:ext cx="777240" cy="256032"/>
           </a:xfrm>
           <a:prstGeom prst="rect">
@@ -7978,50 +7978,6 @@
       <p:grpSpPr/>
       <p:sp>
         <p:nvSpPr>
-          <p:cNvPr id="5" name="Rectangle 4"/>
-          <p:cNvSpPr/>
-          <p:nvPr/>
-        </p:nvSpPr>
-        <p:spPr>
-          <a:xfrm>
-            <a:off x="0" y="0"/>
-            <a:ext cx="12191695" cy="1325880"/>
-          </a:xfrm>
-          <a:prstGeom prst="rect">
-            <a:avLst/>
-          </a:prstGeom>
-          <a:solidFill>
-            <a:srgbClr val="1A3A5C"/>
-          </a:solidFill>
-          <a:ln>
-            <a:noFill/>
-          </a:ln>
-          <a:effectLst/>
-        </p:spPr>
-        <p:style>
-          <a:lnRef idx="1">
-            <a:schemeClr val="accent1"/>
-          </a:lnRef>
-          <a:fillRef idx="3">
-            <a:schemeClr val="accent1"/>
-          </a:fillRef>
-          <a:effectRef idx="2">
-            <a:schemeClr val="accent1"/>
-          </a:effectRef>
-          <a:fontRef idx="minor">
-            <a:schemeClr val="lt1"/>
-          </a:fontRef>
-        </p:style>
-        <p:txBody>
-          <a:bodyPr rtlCol="0" anchor="ctr"/>
-          <a:lstStyle/>
-          <a:p>
-            <a:pPr algn="ctr"/>
-          </a:p>
-        </p:txBody>
-      </p:sp>
-      <p:sp>
-        <p:nvSpPr>
           <p:cNvPr id="2" name="Rectangle 1"/>
           <p:cNvSpPr/>
           <p:nvPr/>
@@ -8145,6 +8101,50 @@
       </p:sp>
       <p:sp>
         <p:nvSpPr>
+          <p:cNvPr id="5" name="Rectangle 4"/>
+          <p:cNvSpPr/>
+          <p:nvPr/>
+        </p:nvSpPr>
+        <p:spPr>
+          <a:xfrm>
+            <a:off x="0" y="0"/>
+            <a:ext cx="12191695" cy="1325880"/>
+          </a:xfrm>
+          <a:prstGeom prst="rect">
+            <a:avLst/>
+          </a:prstGeom>
+          <a:solidFill>
+            <a:srgbClr val="1A3A5C"/>
+          </a:solidFill>
+          <a:ln>
+            <a:noFill/>
+          </a:ln>
+          <a:effectLst/>
+        </p:spPr>
+        <p:style>
+          <a:lnRef idx="1">
+            <a:schemeClr val="accent1"/>
+          </a:lnRef>
+          <a:fillRef idx="3">
+            <a:schemeClr val="accent1"/>
+          </a:fillRef>
+          <a:effectRef idx="2">
+            <a:schemeClr val="accent1"/>
+          </a:effectRef>
+          <a:fontRef idx="minor">
+            <a:schemeClr val="lt1"/>
+          </a:fontRef>
+        </p:style>
+        <p:txBody>
+          <a:bodyPr rtlCol="0" anchor="ctr"/>
+          <a:lstStyle/>
+          <a:p>
+            <a:pPr algn="ctr"/>
+          </a:p>
+        </p:txBody>
+      </p:sp>
+      <p:sp>
+        <p:nvSpPr>
           <p:cNvPr id="6" name="Rectangle 5"/>
           <p:cNvSpPr/>
           <p:nvPr/>
@@ -8964,7 +8964,7 @@
         </p:nvSpPr>
         <p:spPr>
           <a:xfrm>
-            <a:off x="3291840" y="3520440"/>
+            <a:off x="3291840" y="3246120"/>
             <a:ext cx="685800" cy="246888"/>
           </a:xfrm>
           <a:prstGeom prst="rect">
@@ -9052,7 +9052,7 @@
         </p:nvSpPr>
         <p:spPr>
           <a:xfrm>
-            <a:off x="4160520" y="3520440"/>
+            <a:off x="4160520" y="3246120"/>
             <a:ext cx="685800" cy="246888"/>
           </a:xfrm>
           <a:prstGeom prst="rect">
@@ -9140,7 +9140,7 @@
         </p:nvSpPr>
         <p:spPr>
           <a:xfrm>
-            <a:off x="5029200" y="3520440"/>
+            <a:off x="5029200" y="3246120"/>
             <a:ext cx="685800" cy="246888"/>
           </a:xfrm>
           <a:prstGeom prst="rect">
@@ -9547,50 +9547,6 @@
       <p:grpSpPr/>
       <p:sp>
         <p:nvSpPr>
-          <p:cNvPr id="5" name="Rectangle 4"/>
-          <p:cNvSpPr/>
-          <p:nvPr/>
-        </p:nvSpPr>
-        <p:spPr>
-          <a:xfrm>
-            <a:off x="0" y="0"/>
-            <a:ext cx="12191695" cy="1325880"/>
-          </a:xfrm>
-          <a:prstGeom prst="rect">
-            <a:avLst/>
-          </a:prstGeom>
-          <a:solidFill>
-            <a:srgbClr val="1A3A5C"/>
-          </a:solidFill>
-          <a:ln>
-            <a:noFill/>
-          </a:ln>
-          <a:effectLst/>
-        </p:spPr>
-        <p:style>
-          <a:lnRef idx="1">
-            <a:schemeClr val="accent1"/>
-          </a:lnRef>
-          <a:fillRef idx="3">
-            <a:schemeClr val="accent1"/>
-          </a:fillRef>
-          <a:effectRef idx="2">
-            <a:schemeClr val="accent1"/>
-          </a:effectRef>
-          <a:fontRef idx="minor">
-            <a:schemeClr val="lt1"/>
-          </a:fontRef>
-        </p:style>
-        <p:txBody>
-          <a:bodyPr rtlCol="0" anchor="ctr"/>
-          <a:lstStyle/>
-          <a:p>
-            <a:pPr algn="ctr"/>
-          </a:p>
-        </p:txBody>
-      </p:sp>
-      <p:sp>
-        <p:nvSpPr>
           <p:cNvPr id="2" name="Rectangle 1"/>
           <p:cNvSpPr/>
           <p:nvPr/>
@@ -9709,6 +9665,50 @@
               </a:rPr>
               <a:t>Grupo 4: Andrea Añasco · Gema Sepúlveda · Karen Rebolledo · Nicolás Muñoz   |   Caso 86 — Catálogo de Esquemas Tributarios SII 2025</a:t>
             </a:r>
+          </a:p>
+        </p:txBody>
+      </p:sp>
+      <p:sp>
+        <p:nvSpPr>
+          <p:cNvPr id="5" name="Rectangle 4"/>
+          <p:cNvSpPr/>
+          <p:nvPr/>
+        </p:nvSpPr>
+        <p:spPr>
+          <a:xfrm>
+            <a:off x="0" y="0"/>
+            <a:ext cx="12191695" cy="1325880"/>
+          </a:xfrm>
+          <a:prstGeom prst="rect">
+            <a:avLst/>
+          </a:prstGeom>
+          <a:solidFill>
+            <a:srgbClr val="1A3A5C"/>
+          </a:solidFill>
+          <a:ln>
+            <a:noFill/>
+          </a:ln>
+          <a:effectLst/>
+        </p:spPr>
+        <p:style>
+          <a:lnRef idx="1">
+            <a:schemeClr val="accent1"/>
+          </a:lnRef>
+          <a:fillRef idx="3">
+            <a:schemeClr val="accent1"/>
+          </a:fillRef>
+          <a:effectRef idx="2">
+            <a:schemeClr val="accent1"/>
+          </a:effectRef>
+          <a:fontRef idx="minor">
+            <a:schemeClr val="lt1"/>
+          </a:fontRef>
+        </p:style>
+        <p:txBody>
+          <a:bodyPr rtlCol="0" anchor="ctr"/>
+          <a:lstStyle/>
+          <a:p>
+            <a:pPr algn="ctr"/>
           </a:p>
         </p:txBody>
       </p:sp>
@@ -11321,50 +11321,6 @@
       <p:grpSpPr/>
       <p:sp>
         <p:nvSpPr>
-          <p:cNvPr id="5" name="Rectangle 4"/>
-          <p:cNvSpPr/>
-          <p:nvPr/>
-        </p:nvSpPr>
-        <p:spPr>
-          <a:xfrm>
-            <a:off x="0" y="0"/>
-            <a:ext cx="12191695" cy="1325880"/>
-          </a:xfrm>
-          <a:prstGeom prst="rect">
-            <a:avLst/>
-          </a:prstGeom>
-          <a:solidFill>
-            <a:srgbClr val="1A3A5C"/>
-          </a:solidFill>
-          <a:ln>
-            <a:noFill/>
-          </a:ln>
-          <a:effectLst/>
-        </p:spPr>
-        <p:style>
-          <a:lnRef idx="1">
-            <a:schemeClr val="accent1"/>
-          </a:lnRef>
-          <a:fillRef idx="3">
-            <a:schemeClr val="accent1"/>
-          </a:fillRef>
-          <a:effectRef idx="2">
-            <a:schemeClr val="accent1"/>
-          </a:effectRef>
-          <a:fontRef idx="minor">
-            <a:schemeClr val="lt1"/>
-          </a:fontRef>
-        </p:style>
-        <p:txBody>
-          <a:bodyPr rtlCol="0" anchor="ctr"/>
-          <a:lstStyle/>
-          <a:p>
-            <a:pPr algn="ctr"/>
-          </a:p>
-        </p:txBody>
-      </p:sp>
-      <p:sp>
-        <p:nvSpPr>
           <p:cNvPr id="2" name="Rectangle 1"/>
           <p:cNvSpPr/>
           <p:nvPr/>
@@ -11483,6 +11439,50 @@
               </a:rPr>
               <a:t>Grupo 4: Andrea Añasco · Gema Sepúlveda · Karen Rebolledo · Nicolás Muñoz   |   Caso 86 — Catálogo de Esquemas Tributarios SII 2025</a:t>
             </a:r>
+          </a:p>
+        </p:txBody>
+      </p:sp>
+      <p:sp>
+        <p:nvSpPr>
+          <p:cNvPr id="5" name="Rectangle 4"/>
+          <p:cNvSpPr/>
+          <p:nvPr/>
+        </p:nvSpPr>
+        <p:spPr>
+          <a:xfrm>
+            <a:off x="0" y="0"/>
+            <a:ext cx="12191695" cy="1325880"/>
+          </a:xfrm>
+          <a:prstGeom prst="rect">
+            <a:avLst/>
+          </a:prstGeom>
+          <a:solidFill>
+            <a:srgbClr val="1A3A5C"/>
+          </a:solidFill>
+          <a:ln>
+            <a:noFill/>
+          </a:ln>
+          <a:effectLst/>
+        </p:spPr>
+        <p:style>
+          <a:lnRef idx="1">
+            <a:schemeClr val="accent1"/>
+          </a:lnRef>
+          <a:fillRef idx="3">
+            <a:schemeClr val="accent1"/>
+          </a:fillRef>
+          <a:effectRef idx="2">
+            <a:schemeClr val="accent1"/>
+          </a:effectRef>
+          <a:fontRef idx="minor">
+            <a:schemeClr val="lt1"/>
+          </a:fontRef>
+        </p:style>
+        <p:txBody>
+          <a:bodyPr rtlCol="0" anchor="ctr"/>
+          <a:lstStyle/>
+          <a:p>
+            <a:pPr algn="ctr"/>
           </a:p>
         </p:txBody>
       </p:sp>
@@ -12828,50 +12828,6 @@
       <p:grpSpPr/>
       <p:sp>
         <p:nvSpPr>
-          <p:cNvPr id="5" name="Rectangle 4"/>
-          <p:cNvSpPr/>
-          <p:nvPr/>
-        </p:nvSpPr>
-        <p:spPr>
-          <a:xfrm>
-            <a:off x="0" y="0"/>
-            <a:ext cx="12191695" cy="1325880"/>
-          </a:xfrm>
-          <a:prstGeom prst="rect">
-            <a:avLst/>
-          </a:prstGeom>
-          <a:solidFill>
-            <a:srgbClr val="1A3A5C"/>
-          </a:solidFill>
-          <a:ln>
-            <a:noFill/>
-          </a:ln>
-          <a:effectLst/>
-        </p:spPr>
-        <p:style>
-          <a:lnRef idx="1">
-            <a:schemeClr val="accent1"/>
-          </a:lnRef>
-          <a:fillRef idx="3">
-            <a:schemeClr val="accent1"/>
-          </a:fillRef>
-          <a:effectRef idx="2">
-            <a:schemeClr val="accent1"/>
-          </a:effectRef>
-          <a:fontRef idx="minor">
-            <a:schemeClr val="lt1"/>
-          </a:fontRef>
-        </p:style>
-        <p:txBody>
-          <a:bodyPr rtlCol="0" anchor="ctr"/>
-          <a:lstStyle/>
-          <a:p>
-            <a:pPr algn="ctr"/>
-          </a:p>
-        </p:txBody>
-      </p:sp>
-      <p:sp>
-        <p:nvSpPr>
           <p:cNvPr id="2" name="Rectangle 1"/>
           <p:cNvSpPr/>
           <p:nvPr/>
@@ -12990,6 +12946,50 @@
               </a:rPr>
               <a:t>Grupo 4: Andrea Añasco · Gema Sepúlveda · Karen Rebolledo · Nicolás Muñoz   |   Caso 86 — Catálogo de Esquemas Tributarios SII 2025</a:t>
             </a:r>
+          </a:p>
+        </p:txBody>
+      </p:sp>
+      <p:sp>
+        <p:nvSpPr>
+          <p:cNvPr id="5" name="Rectangle 4"/>
+          <p:cNvSpPr/>
+          <p:nvPr/>
+        </p:nvSpPr>
+        <p:spPr>
+          <a:xfrm>
+            <a:off x="0" y="0"/>
+            <a:ext cx="12191695" cy="1325880"/>
+          </a:xfrm>
+          <a:prstGeom prst="rect">
+            <a:avLst/>
+          </a:prstGeom>
+          <a:solidFill>
+            <a:srgbClr val="1A3A5C"/>
+          </a:solidFill>
+          <a:ln>
+            <a:noFill/>
+          </a:ln>
+          <a:effectLst/>
+        </p:spPr>
+        <p:style>
+          <a:lnRef idx="1">
+            <a:schemeClr val="accent1"/>
+          </a:lnRef>
+          <a:fillRef idx="3">
+            <a:schemeClr val="accent1"/>
+          </a:fillRef>
+          <a:effectRef idx="2">
+            <a:schemeClr val="accent1"/>
+          </a:effectRef>
+          <a:fontRef idx="minor">
+            <a:schemeClr val="lt1"/>
+          </a:fontRef>
+        </p:style>
+        <p:txBody>
+          <a:bodyPr rtlCol="0" anchor="ctr"/>
+          <a:lstStyle/>
+          <a:p>
+            <a:pPr algn="ctr"/>
           </a:p>
         </p:txBody>
       </p:sp>

</xml_diff>